<commit_message>
docs: strengthen AI collaboration report
</commit_message>
<xml_diff>
--- a/report/dist/property_shot_game_guide.pptx
+++ b/report/dist/property_shot_game_guide.pptx
@@ -2,24 +2,24 @@
 <file path=ppt/presentation.xml><?xml version="1.0" encoding="utf-8"?>
 <p:presentation xmlns:p="http://schemas.openxmlformats.org/presentationml/2006/main">
   <p:sldMasterIdLst>
-    <p:sldMasterId xmlns:r="http://schemas.openxmlformats.org/officeDocument/2006/relationships" id="2147483648" r:id="R368af97e49644dc2"/>
+    <p:sldMasterId xmlns:r="http://schemas.openxmlformats.org/officeDocument/2006/relationships" id="2147483648" r:id="Ree282ac16d75420f"/>
   </p:sldMasterIdLst>
   <p:notesMasterIdLst>
-    <p:notesMasterId xmlns:r="http://schemas.openxmlformats.org/officeDocument/2006/relationships" r:id="R6486938e4c994ee6"/>
+    <p:notesMasterId xmlns:r="http://schemas.openxmlformats.org/officeDocument/2006/relationships" r:id="R4f32809a8f0c4a79"/>
   </p:notesMasterIdLst>
   <p:sldIdLst>
-    <p:sldId xmlns:r="http://schemas.openxmlformats.org/officeDocument/2006/relationships" id="256" r:id="R73e975c69bf4435c"/>
-    <p:sldId xmlns:r="http://schemas.openxmlformats.org/officeDocument/2006/relationships" id="257" r:id="R131cabca8a824ccc"/>
-    <p:sldId xmlns:r="http://schemas.openxmlformats.org/officeDocument/2006/relationships" id="258" r:id="R61cd083110794d37"/>
-    <p:sldId xmlns:r="http://schemas.openxmlformats.org/officeDocument/2006/relationships" id="259" r:id="R65ec918b927f4e45"/>
-    <p:sldId xmlns:r="http://schemas.openxmlformats.org/officeDocument/2006/relationships" id="260" r:id="Rbb22814aa1dd4ef8"/>
-    <p:sldId xmlns:r="http://schemas.openxmlformats.org/officeDocument/2006/relationships" id="261" r:id="Rdc24087fb81448e0"/>
-    <p:sldId xmlns:r="http://schemas.openxmlformats.org/officeDocument/2006/relationships" id="262" r:id="R16ab52cda82247ed"/>
-    <p:sldId xmlns:r="http://schemas.openxmlformats.org/officeDocument/2006/relationships" id="263" r:id="Rb7684d2334d545e9"/>
-    <p:sldId xmlns:r="http://schemas.openxmlformats.org/officeDocument/2006/relationships" id="264" r:id="R08d62acf08c440d7"/>
-    <p:sldId xmlns:r="http://schemas.openxmlformats.org/officeDocument/2006/relationships" id="265" r:id="R1934462de58b41d7"/>
-    <p:sldId xmlns:r="http://schemas.openxmlformats.org/officeDocument/2006/relationships" id="266" r:id="Rd1d66fa2ab8b443b"/>
-    <p:sldId xmlns:r="http://schemas.openxmlformats.org/officeDocument/2006/relationships" id="267" r:id="R142f25d719734c58"/>
+    <p:sldId xmlns:r="http://schemas.openxmlformats.org/officeDocument/2006/relationships" id="256" r:id="R4d8bfd827231428d"/>
+    <p:sldId xmlns:r="http://schemas.openxmlformats.org/officeDocument/2006/relationships" id="257" r:id="R1ad65ab75c024eda"/>
+    <p:sldId xmlns:r="http://schemas.openxmlformats.org/officeDocument/2006/relationships" id="258" r:id="R72d5cbbfafbc420e"/>
+    <p:sldId xmlns:r="http://schemas.openxmlformats.org/officeDocument/2006/relationships" id="259" r:id="R8b103e558aaf4941"/>
+    <p:sldId xmlns:r="http://schemas.openxmlformats.org/officeDocument/2006/relationships" id="260" r:id="R2c31025a64cc40fe"/>
+    <p:sldId xmlns:r="http://schemas.openxmlformats.org/officeDocument/2006/relationships" id="261" r:id="R1b661c13074746d0"/>
+    <p:sldId xmlns:r="http://schemas.openxmlformats.org/officeDocument/2006/relationships" id="262" r:id="Ra001bf336db64287"/>
+    <p:sldId xmlns:r="http://schemas.openxmlformats.org/officeDocument/2006/relationships" id="263" r:id="Rbccddd095b6d4ca7"/>
+    <p:sldId xmlns:r="http://schemas.openxmlformats.org/officeDocument/2006/relationships" id="264" r:id="R2a87071d618a41b2"/>
+    <p:sldId xmlns:r="http://schemas.openxmlformats.org/officeDocument/2006/relationships" id="265" r:id="R3113e297d70d4c32"/>
+    <p:sldId xmlns:r="http://schemas.openxmlformats.org/officeDocument/2006/relationships" id="266" r:id="R4b777c2bc486434d"/>
+    <p:sldId xmlns:r="http://schemas.openxmlformats.org/officeDocument/2006/relationships" id="267" r:id="Rd041eadbec0c4e4e"/>
   </p:sldIdLst>
   <p:sldSz cx="7562850" cy="10696575"/>
   <p:notesSz cx="6858000" cy="9144000"/>
@@ -1406,7 +1406,7 @@
   </p:cSld>
   <p:clrMap bg1="lt1" tx1="dk1" bg2="lt2" tx2="dk2" accent1="accent1" accent2="accent2" accent3="accent3" accent4="accent4" accent5="accent5" accent6="accent6" hlink="hlink" folHlink="folHlink"/>
   <p:sldLayoutIdLst>
-    <p:sldLayoutId xmlns:r="http://schemas.openxmlformats.org/officeDocument/2006/relationships" id="2147483649" r:id="R91096985357b40cc"/>
+    <p:sldLayoutId xmlns:r="http://schemas.openxmlformats.org/officeDocument/2006/relationships" id="2147483649" r:id="R0bbb3ded0301492c"/>
   </p:sldLayoutIdLst>
   <p:txStyles>
     <p:titleStyle>
@@ -1954,10 +1954,10 @@
       </p:grpSpPr>
       <p:sp>
         <p:nvSpPr>
-          <p:cNvPr id="9" name="cover-accent">
-            <a:extLst xmlns:a="http://schemas.openxmlformats.org/drawingml/2006/main">
-              <a:ext uri="{FF2B5EF4-FFF2-40B4-BE49-F238E27FC236}">
-                <a16:creationId xmlns:a16="http://schemas.microsoft.com/office/drawing/2014/main" id="{605AD8F1-A673-415D-9573-CCD0247210F7}"/>
+          <p:cNvPr id="8" name="cover-accent">
+            <a:extLst xmlns:a="http://schemas.openxmlformats.org/drawingml/2006/main">
+              <a:ext uri="{FF2B5EF4-FFF2-40B4-BE49-F238E27FC236}">
+                <a16:creationId xmlns:a16="http://schemas.microsoft.com/office/drawing/2014/main" id="{4724B758-BB45-45C9-8A1F-6FFDCBFF806A}"/>
               </a:ext>
             </a:extLst>
           </p:cNvPr>
@@ -1988,7 +1988,7 @@
           <p:cNvPr id="2" name="cover-kicker">
             <a:extLst xmlns:a="http://schemas.openxmlformats.org/drawingml/2006/main">
               <a:ext uri="{FF2B5EF4-FFF2-40B4-BE49-F238E27FC236}">
-                <a16:creationId xmlns:a16="http://schemas.microsoft.com/office/drawing/2014/main" id="{E4E61D72-8AC1-4012-A146-6ADAAD4735B8}"/>
+                <a16:creationId xmlns:a16="http://schemas.microsoft.com/office/drawing/2014/main" id="{D5EFF48B-8441-4F56-B753-9645F2F3FE3B}"/>
               </a:ext>
             </a:extLst>
           </p:cNvPr>
@@ -2050,7 +2050,7 @@
           <p:cNvPr id="3" name="cover-title">
             <a:extLst xmlns:a="http://schemas.openxmlformats.org/drawingml/2006/main">
               <a:ext uri="{FF2B5EF4-FFF2-40B4-BE49-F238E27FC236}">
-                <a16:creationId xmlns:a16="http://schemas.microsoft.com/office/drawing/2014/main" id="{43ED7C57-2631-4033-B422-E3D8C93A730A}"/>
+                <a16:creationId xmlns:a16="http://schemas.microsoft.com/office/drawing/2014/main" id="{1ABB6B82-FD73-4ED2-A431-9AD46232B89D}"/>
               </a:ext>
             </a:extLst>
           </p:cNvPr>
@@ -2112,7 +2112,7 @@
           <p:cNvPr id="4" name="cover-rule">
             <a:extLst xmlns:a="http://schemas.openxmlformats.org/drawingml/2006/main">
               <a:ext uri="{FF2B5EF4-FFF2-40B4-BE49-F238E27FC236}">
-                <a16:creationId xmlns:a16="http://schemas.microsoft.com/office/drawing/2014/main" id="{B6A9B6FE-EE2E-4460-99A7-C0FAD5D49F1D}"/>
+                <a16:creationId xmlns:a16="http://schemas.microsoft.com/office/drawing/2014/main" id="{0AFE86AA-20E1-4E84-8BBC-C13E7AD8ED23}"/>
               </a:ext>
             </a:extLst>
           </p:cNvPr>
@@ -2138,83 +2138,21 @@
           </a:ln>
         </p:spPr>
       </p:sp>
-      <p:sp>
-        <p:nvSpPr>
-          <p:cNvPr id="5" name="cover-description">
-            <a:extLst xmlns:a="http://schemas.openxmlformats.org/drawingml/2006/main">
-              <a:ext uri="{FF2B5EF4-FFF2-40B4-BE49-F238E27FC236}">
-                <a16:creationId xmlns:a16="http://schemas.microsoft.com/office/drawing/2014/main" id="{4CAF1B77-CA17-4F1F-A48E-8A82ADB3CDAC}"/>
-              </a:ext>
-            </a:extLst>
-          </p:cNvPr>
-          <p:cNvSpPr>
-            <a:spLocks xmlns:a="http://schemas.openxmlformats.org/drawingml/2006/main" noGrp="1"/>
-          </p:cNvSpPr>
-          <p:nvPr/>
-        </p:nvSpPr>
-        <p:spPr>
-          <a:xfrm xmlns:a="http://schemas.openxmlformats.org/drawingml/2006/main">
-            <a:off x="742950" y="4552950"/>
-            <a:ext cx="3238500" cy="1524000"/>
-          </a:xfrm>
-          <a:prstGeom xmlns:a="http://schemas.openxmlformats.org/drawingml/2006/main" prst="rect">
-            <a:avLst/>
-          </a:prstGeom>
-          <a:noFill xmlns:a="http://schemas.openxmlformats.org/drawingml/2006/main"/>
-          <a:ln xmlns:a="http://schemas.openxmlformats.org/drawingml/2006/main" w="0">
-            <a:noFill/>
-            <a:prstDash val="solid"/>
-          </a:ln>
-        </p:spPr>
-        <p:txBody>
-          <a:bodyPr xmlns:a="http://schemas.openxmlformats.org/drawingml/2006/main" lIns="0" tIns="0" rIns="0" bIns="0" anchor="t">
-            <a:normAutofit fontScale="100000"/>
-          </a:bodyPr>
-          <a:lstStyle xmlns:a="http://schemas.openxmlformats.org/drawingml/2006/main"/>
-          <a:p xmlns:a="http://schemas.openxmlformats.org/drawingml/2006/main">
-            <a:pPr algn="l">
-              <a:lnSpc>
-                <a:spcPct val="125000"/>
-              </a:lnSpc>
-              <a:buNone/>
-              <a:defRPr sz="1650" b="0">
-                <a:solidFill>
-                  <a:srgbClr val="607477"/>
-                </a:solidFill>
-                <a:latin typeface="NanumGothic"/>
-                <a:ea typeface="NanumGothic"/>
-                <a:cs typeface="NanumGothic"/>
-              </a:defRPr>
-            </a:pPr>
-            <a:r>
-              <a:rPr sz="1650" b="0">
-                <a:solidFill>
-                  <a:srgbClr val="607477"/>
-                </a:solidFill>
-                <a:latin typeface="NanumGothic"/>
-                <a:ea typeface="NanumGothic"/>
-                <a:cs typeface="NanumGothic"/>
-              </a:rPr>
-              <a:t>속성을 옮기고, 실패까지 다음 해법으로 바꾸는 물리 퍼즐</a:t>
-            </a:r>
-          </a:p>
-        </p:txBody>
-      </p:sp>
       <p:pic>
         <p:nvPicPr>
-          <p:cNvPr id="14" name=""/>
+          <p:cNvPr id="12" name=""/>
           <p:cNvPicPr>
             <a:picLocks xmlns:a="http://schemas.openxmlformats.org/drawingml/2006/main" noChangeAspect="1"/>
           </p:cNvPicPr>
           <p:nvPr/>
         </p:nvPicPr>
         <p:blipFill>
-          <a:blip xmlns:r="http://schemas.openxmlformats.org/officeDocument/2006/relationships" xmlns:a="http://schemas.openxmlformats.org/drawingml/2006/main" r:embed="R06a9491bbc6e4312"/>
+          <a:blip xmlns:r="http://schemas.openxmlformats.org/officeDocument/2006/relationships" xmlns:a="http://schemas.openxmlformats.org/drawingml/2006/main" r:embed="R0bb0dafe3b774694"/>
           <a:stretch xmlns:a="http://schemas.openxmlformats.org/drawingml/2006/main"/>
         </p:blipFill>
         <p:spPr>
           <a:xfrm xmlns:a="http://schemas.openxmlformats.org/drawingml/2006/main">
-            <a:off x="4845900" y="4457700"/>
+            <a:off x="3055200" y="4457700"/>
             <a:ext cx="1452450" cy="3143250"/>
           </a:xfrm>
           <a:prstGeom xmlns:a="http://schemas.openxmlformats.org/drawingml/2006/main" prst="roundRect">
@@ -2226,10 +2164,10 @@
       </p:pic>
       <p:sp>
         <p:nvSpPr>
-          <p:cNvPr id="7" name="cover-meta">
-            <a:extLst xmlns:a="http://schemas.openxmlformats.org/drawingml/2006/main">
-              <a:ext uri="{FF2B5EF4-FFF2-40B4-BE49-F238E27FC236}">
-                <a16:creationId xmlns:a16="http://schemas.microsoft.com/office/drawing/2014/main" id="{292EE0A4-8833-43D8-8094-E8AB0C1EAC0C}"/>
+          <p:cNvPr id="6" name="cover-meta">
+            <a:extLst xmlns:a="http://schemas.openxmlformats.org/drawingml/2006/main">
+              <a:ext uri="{FF2B5EF4-FFF2-40B4-BE49-F238E27FC236}">
+                <a16:creationId xmlns:a16="http://schemas.microsoft.com/office/drawing/2014/main" id="{AE943181-3CD1-4974-8DCD-A59DE784D31C}"/>
               </a:ext>
             </a:extLst>
           </p:cNvPr>
@@ -2315,10 +2253,10 @@
       </p:sp>
       <p:sp>
         <p:nvSpPr>
-          <p:cNvPr id="8" name="cover-page">
-            <a:extLst xmlns:a="http://schemas.openxmlformats.org/drawingml/2006/main">
-              <a:ext uri="{FF2B5EF4-FFF2-40B4-BE49-F238E27FC236}">
-                <a16:creationId xmlns:a16="http://schemas.microsoft.com/office/drawing/2014/main" id="{FCE6C4F5-CEDC-40A9-B433-E87532787AFD}"/>
+          <p:cNvPr id="7" name="cover-page">
+            <a:extLst xmlns:a="http://schemas.openxmlformats.org/drawingml/2006/main">
+              <a:ext uri="{FF2B5EF4-FFF2-40B4-BE49-F238E27FC236}">
+                <a16:creationId xmlns:a16="http://schemas.microsoft.com/office/drawing/2014/main" id="{B6481D57-8A79-43A8-816D-F06E5DCEFEEC}"/>
               </a:ext>
             </a:extLst>
           </p:cNvPr>
@@ -2378,7 +2316,7 @@
     </p:spTree>
     <p:extLst>
       <p:ext uri="{BB962C8B-B14F-4D97-AF65-F5344CB8AC3E}">
-        <p14:creationId xmlns:p14="http://schemas.microsoft.com/office/powerpoint/2010/main" val="1767605553"/>
+        <p14:creationId xmlns:p14="http://schemas.microsoft.com/office/powerpoint/2010/main" val="390812442"/>
       </p:ext>
     </p:extLst>
   </p:cSld>
@@ -2409,7 +2347,7 @@
           <p:cNvPr id="10" name="running-label">
             <a:extLst xmlns:a="http://schemas.openxmlformats.org/drawingml/2006/main">
               <a:ext uri="{FF2B5EF4-FFF2-40B4-BE49-F238E27FC236}">
-                <a16:creationId xmlns:a16="http://schemas.microsoft.com/office/drawing/2014/main" id="{F51D6401-3F44-4F88-A962-489BA2267A7D}"/>
+                <a16:creationId xmlns:a16="http://schemas.microsoft.com/office/drawing/2014/main" id="{FC28CA8F-87A6-4B30-B761-9E3FBC6A1ABB}"/>
               </a:ext>
             </a:extLst>
           </p:cNvPr>
@@ -2471,7 +2409,7 @@
           <p:cNvPr id="2" name="page-number">
             <a:extLst xmlns:a="http://schemas.openxmlformats.org/drawingml/2006/main">
               <a:ext uri="{FF2B5EF4-FFF2-40B4-BE49-F238E27FC236}">
-                <a16:creationId xmlns:a16="http://schemas.microsoft.com/office/drawing/2014/main" id="{A051B96E-5F8C-47A1-A1AE-73BAE952B779}"/>
+                <a16:creationId xmlns:a16="http://schemas.microsoft.com/office/drawing/2014/main" id="{27C22B41-706B-4757-8CFE-26BF0ECDFC0B}"/>
               </a:ext>
             </a:extLst>
           </p:cNvPr>
@@ -2533,7 +2471,7 @@
           <p:cNvPr id="3" name="header-rule">
             <a:extLst xmlns:a="http://schemas.openxmlformats.org/drawingml/2006/main">
               <a:ext uri="{FF2B5EF4-FFF2-40B4-BE49-F238E27FC236}">
-                <a16:creationId xmlns:a16="http://schemas.microsoft.com/office/drawing/2014/main" id="{4355B4C0-22BA-4176-B5A1-A436944613E9}"/>
+                <a16:creationId xmlns:a16="http://schemas.microsoft.com/office/drawing/2014/main" id="{C88C919A-1B6F-42E9-9519-F0CC1F4BDD13}"/>
               </a:ext>
             </a:extLst>
           </p:cNvPr>
@@ -2564,7 +2502,7 @@
           <p:cNvPr id="4" name="slide-title">
             <a:extLst xmlns:a="http://schemas.openxmlformats.org/drawingml/2006/main">
               <a:ext uri="{FF2B5EF4-FFF2-40B4-BE49-F238E27FC236}">
-                <a16:creationId xmlns:a16="http://schemas.microsoft.com/office/drawing/2014/main" id="{7DF23D58-A6B4-489E-808D-BD22188C2972}"/>
+                <a16:creationId xmlns:a16="http://schemas.microsoft.com/office/drawing/2014/main" id="{B1FF041B-677D-427E-A717-EEDD7A8E8E89}"/>
               </a:ext>
             </a:extLst>
           </p:cNvPr>
@@ -2626,7 +2564,7 @@
           <p:cNvPr id="5" name="subheading-140">
             <a:extLst xmlns:a="http://schemas.openxmlformats.org/drawingml/2006/main">
               <a:ext uri="{FF2B5EF4-FFF2-40B4-BE49-F238E27FC236}">
-                <a16:creationId xmlns:a16="http://schemas.microsoft.com/office/drawing/2014/main" id="{0310B234-5B14-4D4F-B372-E62D7C5F7B24}"/>
+                <a16:creationId xmlns:a16="http://schemas.microsoft.com/office/drawing/2014/main" id="{DBFA952F-4F52-4681-AC4D-278857C4363C}"/>
               </a:ext>
             </a:extLst>
           </p:cNvPr>
@@ -2688,7 +2626,7 @@
           <p:cNvPr id="6" name="paragraph-194">
             <a:extLst xmlns:a="http://schemas.openxmlformats.org/drawingml/2006/main">
               <a:ext uri="{FF2B5EF4-FFF2-40B4-BE49-F238E27FC236}">
-                <a16:creationId xmlns:a16="http://schemas.microsoft.com/office/drawing/2014/main" id="{8B30C84D-D6FF-4B90-9F62-6ACEAE9AA9BC}"/>
+                <a16:creationId xmlns:a16="http://schemas.microsoft.com/office/drawing/2014/main" id="{C0259B48-F08C-4C44-8B28-88BBB52F7679}"/>
               </a:ext>
             </a:extLst>
           </p:cNvPr>
@@ -2750,7 +2688,7 @@
           <p:cNvPr id="7" name="subheading-290.96000000000004">
             <a:extLst xmlns:a="http://schemas.openxmlformats.org/drawingml/2006/main">
               <a:ext uri="{FF2B5EF4-FFF2-40B4-BE49-F238E27FC236}">
-                <a16:creationId xmlns:a16="http://schemas.microsoft.com/office/drawing/2014/main" id="{5AFF2B7B-AD6F-4E10-A75E-7BAA4140A9FC}"/>
+                <a16:creationId xmlns:a16="http://schemas.microsoft.com/office/drawing/2014/main" id="{7A2D29C2-B902-47E4-A152-73156F2350FF}"/>
               </a:ext>
             </a:extLst>
           </p:cNvPr>
@@ -2812,7 +2750,7 @@
           <p:cNvPr id="8" name="paragraph-344.96000000000004">
             <a:extLst xmlns:a="http://schemas.openxmlformats.org/drawingml/2006/main">
               <a:ext uri="{FF2B5EF4-FFF2-40B4-BE49-F238E27FC236}">
-                <a16:creationId xmlns:a16="http://schemas.microsoft.com/office/drawing/2014/main" id="{6FB86190-89CA-4E27-9BE4-1509A1B751AF}"/>
+                <a16:creationId xmlns:a16="http://schemas.microsoft.com/office/drawing/2014/main" id="{2CED0051-94B5-455F-BCFF-EBD3A6994F93}"/>
               </a:ext>
             </a:extLst>
           </p:cNvPr>
@@ -2874,7 +2812,7 @@
           <p:cNvPr id="9" name="paragraph-466.24">
             <a:extLst xmlns:a="http://schemas.openxmlformats.org/drawingml/2006/main">
               <a:ext uri="{FF2B5EF4-FFF2-40B4-BE49-F238E27FC236}">
-                <a16:creationId xmlns:a16="http://schemas.microsoft.com/office/drawing/2014/main" id="{36BA369B-9D8A-4FE2-8C05-5CFF72F02FE7}"/>
+                <a16:creationId xmlns:a16="http://schemas.microsoft.com/office/drawing/2014/main" id="{F2E97EE7-B636-4167-B8AA-B86AEFDA2E4B}"/>
               </a:ext>
             </a:extLst>
           </p:cNvPr>
@@ -2934,7 +2872,7 @@
     </p:spTree>
     <p:extLst>
       <p:ext uri="{BB962C8B-B14F-4D97-AF65-F5344CB8AC3E}">
-        <p14:creationId xmlns:p14="http://schemas.microsoft.com/office/powerpoint/2010/main" val="2070522580"/>
+        <p14:creationId xmlns:p14="http://schemas.microsoft.com/office/powerpoint/2010/main" val="975631698"/>
       </p:ext>
     </p:extLst>
   </p:cSld>
@@ -2965,7 +2903,7 @@
           <p:cNvPr id="10" name="running-label">
             <a:extLst xmlns:a="http://schemas.openxmlformats.org/drawingml/2006/main">
               <a:ext uri="{FF2B5EF4-FFF2-40B4-BE49-F238E27FC236}">
-                <a16:creationId xmlns:a16="http://schemas.microsoft.com/office/drawing/2014/main" id="{83F46B81-D785-485A-B2D2-FC37EAEDFBF4}"/>
+                <a16:creationId xmlns:a16="http://schemas.microsoft.com/office/drawing/2014/main" id="{8B4D891A-FD96-43F1-9266-984F51D48813}"/>
               </a:ext>
             </a:extLst>
           </p:cNvPr>
@@ -3027,7 +2965,7 @@
           <p:cNvPr id="2" name="page-number">
             <a:extLst xmlns:a="http://schemas.openxmlformats.org/drawingml/2006/main">
               <a:ext uri="{FF2B5EF4-FFF2-40B4-BE49-F238E27FC236}">
-                <a16:creationId xmlns:a16="http://schemas.microsoft.com/office/drawing/2014/main" id="{265BA90F-EFEE-44C3-A782-B3A90047C7E2}"/>
+                <a16:creationId xmlns:a16="http://schemas.microsoft.com/office/drawing/2014/main" id="{15F6E0DA-F2DF-447B-8745-168E33847DAC}"/>
               </a:ext>
             </a:extLst>
           </p:cNvPr>
@@ -3089,7 +3027,7 @@
           <p:cNvPr id="3" name="header-rule">
             <a:extLst xmlns:a="http://schemas.openxmlformats.org/drawingml/2006/main">
               <a:ext uri="{FF2B5EF4-FFF2-40B4-BE49-F238E27FC236}">
-                <a16:creationId xmlns:a16="http://schemas.microsoft.com/office/drawing/2014/main" id="{BB4BB484-848B-49A8-A9FC-7177DFC26B5E}"/>
+                <a16:creationId xmlns:a16="http://schemas.microsoft.com/office/drawing/2014/main" id="{EB919228-E080-4D78-8060-2A411763F88E}"/>
               </a:ext>
             </a:extLst>
           </p:cNvPr>
@@ -3120,7 +3058,7 @@
           <p:cNvPr id="4" name="slide-title">
             <a:extLst xmlns:a="http://schemas.openxmlformats.org/drawingml/2006/main">
               <a:ext uri="{FF2B5EF4-FFF2-40B4-BE49-F238E27FC236}">
-                <a16:creationId xmlns:a16="http://schemas.microsoft.com/office/drawing/2014/main" id="{CBA1B363-57EB-496B-910B-169913A9E773}"/>
+                <a16:creationId xmlns:a16="http://schemas.microsoft.com/office/drawing/2014/main" id="{9886ADD6-C9EA-4A84-BAE6-ACB5C9C02943}"/>
               </a:ext>
             </a:extLst>
           </p:cNvPr>
@@ -3182,7 +3120,7 @@
           <p:cNvPr id="5" name="subheading-140">
             <a:extLst xmlns:a="http://schemas.openxmlformats.org/drawingml/2006/main">
               <a:ext uri="{FF2B5EF4-FFF2-40B4-BE49-F238E27FC236}">
-                <a16:creationId xmlns:a16="http://schemas.microsoft.com/office/drawing/2014/main" id="{42828070-7FD3-4146-9AD4-DB56AB74C20A}"/>
+                <a16:creationId xmlns:a16="http://schemas.microsoft.com/office/drawing/2014/main" id="{1F38039D-1F35-4B6E-9FA0-6FE048691D33}"/>
               </a:ext>
             </a:extLst>
           </p:cNvPr>
@@ -3244,7 +3182,7 @@
           <p:cNvPr id="6" name="paragraph-194">
             <a:extLst xmlns:a="http://schemas.openxmlformats.org/drawingml/2006/main">
               <a:ext uri="{FF2B5EF4-FFF2-40B4-BE49-F238E27FC236}">
-                <a16:creationId xmlns:a16="http://schemas.microsoft.com/office/drawing/2014/main" id="{E29CF93B-C7BC-4094-B48B-F629FB824197}"/>
+                <a16:creationId xmlns:a16="http://schemas.microsoft.com/office/drawing/2014/main" id="{A0A0A4C5-4F4A-42B2-ADB5-A54B589A9B11}"/>
               </a:ext>
             </a:extLst>
           </p:cNvPr>
@@ -3306,7 +3244,7 @@
           <p:cNvPr id="7" name="paragraph-242.32">
             <a:extLst xmlns:a="http://schemas.openxmlformats.org/drawingml/2006/main">
               <a:ext uri="{FF2B5EF4-FFF2-40B4-BE49-F238E27FC236}">
-                <a16:creationId xmlns:a16="http://schemas.microsoft.com/office/drawing/2014/main" id="{4C5407EC-2576-4A34-84B1-F5BD3A41AFAA}"/>
+                <a16:creationId xmlns:a16="http://schemas.microsoft.com/office/drawing/2014/main" id="{0D44D0BD-BA4F-4E8C-84B6-96810C20AA42}"/>
               </a:ext>
             </a:extLst>
           </p:cNvPr>
@@ -3368,7 +3306,7 @@
           <p:cNvPr id="8" name="subheading-314.96">
             <a:extLst xmlns:a="http://schemas.openxmlformats.org/drawingml/2006/main">
               <a:ext uri="{FF2B5EF4-FFF2-40B4-BE49-F238E27FC236}">
-                <a16:creationId xmlns:a16="http://schemas.microsoft.com/office/drawing/2014/main" id="{33E67405-5C2A-4220-B7B7-B79E910757A4}"/>
+                <a16:creationId xmlns:a16="http://schemas.microsoft.com/office/drawing/2014/main" id="{C9246495-CE8D-4B55-85B6-AE1500504DAA}"/>
               </a:ext>
             </a:extLst>
           </p:cNvPr>
@@ -3430,7 +3368,7 @@
           <p:cNvPr id="9" name="paragraph-368.96">
             <a:extLst xmlns:a="http://schemas.openxmlformats.org/drawingml/2006/main">
               <a:ext uri="{FF2B5EF4-FFF2-40B4-BE49-F238E27FC236}">
-                <a16:creationId xmlns:a16="http://schemas.microsoft.com/office/drawing/2014/main" id="{563CD26D-98F0-4807-ACCB-95B543789D11}"/>
+                <a16:creationId xmlns:a16="http://schemas.microsoft.com/office/drawing/2014/main" id="{9CC45E7D-5977-40CC-A56B-E7CB14D364C1}"/>
               </a:ext>
             </a:extLst>
           </p:cNvPr>
@@ -3490,7 +3428,7 @@
     </p:spTree>
     <p:extLst>
       <p:ext uri="{BB962C8B-B14F-4D97-AF65-F5344CB8AC3E}">
-        <p14:creationId xmlns:p14="http://schemas.microsoft.com/office/powerpoint/2010/main" val="81872620"/>
+        <p14:creationId xmlns:p14="http://schemas.microsoft.com/office/powerpoint/2010/main" val="1036388248"/>
       </p:ext>
     </p:extLst>
   </p:cSld>
@@ -3521,7 +3459,7 @@
           <p:cNvPr id="25" name="running-label">
             <a:extLst xmlns:a="http://schemas.openxmlformats.org/drawingml/2006/main">
               <a:ext uri="{FF2B5EF4-FFF2-40B4-BE49-F238E27FC236}">
-                <a16:creationId xmlns:a16="http://schemas.microsoft.com/office/drawing/2014/main" id="{4646ED87-512D-4CE4-8458-77F852ACFB0D}"/>
+                <a16:creationId xmlns:a16="http://schemas.microsoft.com/office/drawing/2014/main" id="{37E3CEEC-8D8B-4F9D-8824-FFC5ED274EA6}"/>
               </a:ext>
             </a:extLst>
           </p:cNvPr>
@@ -3583,7 +3521,7 @@
           <p:cNvPr id="2" name="page-number">
             <a:extLst xmlns:a="http://schemas.openxmlformats.org/drawingml/2006/main">
               <a:ext uri="{FF2B5EF4-FFF2-40B4-BE49-F238E27FC236}">
-                <a16:creationId xmlns:a16="http://schemas.microsoft.com/office/drawing/2014/main" id="{BEC3CAB9-77ED-4FE8-B393-84285B69496E}"/>
+                <a16:creationId xmlns:a16="http://schemas.microsoft.com/office/drawing/2014/main" id="{6B0D723F-5B92-4483-B527-96872A125149}"/>
               </a:ext>
             </a:extLst>
           </p:cNvPr>
@@ -3645,7 +3583,7 @@
           <p:cNvPr id="3" name="header-rule">
             <a:extLst xmlns:a="http://schemas.openxmlformats.org/drawingml/2006/main">
               <a:ext uri="{FF2B5EF4-FFF2-40B4-BE49-F238E27FC236}">
-                <a16:creationId xmlns:a16="http://schemas.microsoft.com/office/drawing/2014/main" id="{D591CA33-7001-4C54-A850-9307A1F9F874}"/>
+                <a16:creationId xmlns:a16="http://schemas.microsoft.com/office/drawing/2014/main" id="{4B8BC1BC-D449-4AFB-930D-42DC1C8F7400}"/>
               </a:ext>
             </a:extLst>
           </p:cNvPr>
@@ -3676,7 +3614,7 @@
           <p:cNvPr id="4" name="slide-title">
             <a:extLst xmlns:a="http://schemas.openxmlformats.org/drawingml/2006/main">
               <a:ext uri="{FF2B5EF4-FFF2-40B4-BE49-F238E27FC236}">
-                <a16:creationId xmlns:a16="http://schemas.microsoft.com/office/drawing/2014/main" id="{46D60796-3E8E-4387-BE74-4803D0971158}"/>
+                <a16:creationId xmlns:a16="http://schemas.microsoft.com/office/drawing/2014/main" id="{301D6976-59D2-4F85-9AAA-CEE18EB22297}"/>
               </a:ext>
             </a:extLst>
           </p:cNvPr>
@@ -3738,7 +3676,7 @@
           <p:cNvPr id="5" name="table-cell-140-0-0">
             <a:extLst xmlns:a="http://schemas.openxmlformats.org/drawingml/2006/main">
               <a:ext uri="{FF2B5EF4-FFF2-40B4-BE49-F238E27FC236}">
-                <a16:creationId xmlns:a16="http://schemas.microsoft.com/office/drawing/2014/main" id="{90C80871-B940-44EF-8179-7A88493F0FA0}"/>
+                <a16:creationId xmlns:a16="http://schemas.microsoft.com/office/drawing/2014/main" id="{2D816BF0-57BE-4A77-84E2-7C84A84D608C}"/>
               </a:ext>
             </a:extLst>
           </p:cNvPr>
@@ -3771,7 +3709,7 @@
           <p:cNvPr id="6" name="table-text-140-0-0">
             <a:extLst xmlns:a="http://schemas.openxmlformats.org/drawingml/2006/main">
               <a:ext uri="{FF2B5EF4-FFF2-40B4-BE49-F238E27FC236}">
-                <a16:creationId xmlns:a16="http://schemas.microsoft.com/office/drawing/2014/main" id="{EE6FCFF6-5F47-4C23-B810-BA296E5EAFA0}"/>
+                <a16:creationId xmlns:a16="http://schemas.microsoft.com/office/drawing/2014/main" id="{5BA2D542-553B-43AF-B24B-1B6208F182D1}"/>
               </a:ext>
             </a:extLst>
           </p:cNvPr>
@@ -3833,7 +3771,7 @@
           <p:cNvPr id="7" name="table-cell-140-0-1">
             <a:extLst xmlns:a="http://schemas.openxmlformats.org/drawingml/2006/main">
               <a:ext uri="{FF2B5EF4-FFF2-40B4-BE49-F238E27FC236}">
-                <a16:creationId xmlns:a16="http://schemas.microsoft.com/office/drawing/2014/main" id="{3452E89C-8370-41F1-9B01-F19C4BC5B2DA}"/>
+                <a16:creationId xmlns:a16="http://schemas.microsoft.com/office/drawing/2014/main" id="{03632134-A7DA-4496-AF57-8410BC22B8A2}"/>
               </a:ext>
             </a:extLst>
           </p:cNvPr>
@@ -3866,7 +3804,7 @@
           <p:cNvPr id="8" name="table-text-140-0-1">
             <a:extLst xmlns:a="http://schemas.openxmlformats.org/drawingml/2006/main">
               <a:ext uri="{FF2B5EF4-FFF2-40B4-BE49-F238E27FC236}">
-                <a16:creationId xmlns:a16="http://schemas.microsoft.com/office/drawing/2014/main" id="{DA6F370C-409D-4478-83C8-7882DC9D0527}"/>
+                <a16:creationId xmlns:a16="http://schemas.microsoft.com/office/drawing/2014/main" id="{40D390D0-1A7D-4125-AC08-DC69D6FE870C}"/>
               </a:ext>
             </a:extLst>
           </p:cNvPr>
@@ -3928,7 +3866,7 @@
           <p:cNvPr id="9" name="table-cell-140-1-0">
             <a:extLst xmlns:a="http://schemas.openxmlformats.org/drawingml/2006/main">
               <a:ext uri="{FF2B5EF4-FFF2-40B4-BE49-F238E27FC236}">
-                <a16:creationId xmlns:a16="http://schemas.microsoft.com/office/drawing/2014/main" id="{BF07576B-3337-4096-9366-398A0FF4C692}"/>
+                <a16:creationId xmlns:a16="http://schemas.microsoft.com/office/drawing/2014/main" id="{2796BBA7-C767-4C5A-9521-180BDFDD5406}"/>
               </a:ext>
             </a:extLst>
           </p:cNvPr>
@@ -3961,7 +3899,7 @@
           <p:cNvPr id="10" name="table-text-140-1-0">
             <a:extLst xmlns:a="http://schemas.openxmlformats.org/drawingml/2006/main">
               <a:ext uri="{FF2B5EF4-FFF2-40B4-BE49-F238E27FC236}">
-                <a16:creationId xmlns:a16="http://schemas.microsoft.com/office/drawing/2014/main" id="{3968CBC1-1F1A-42A6-ACFE-E205EB144B2B}"/>
+                <a16:creationId xmlns:a16="http://schemas.microsoft.com/office/drawing/2014/main" id="{BE67A96A-3766-4C00-93BE-22E8367E4BA1}"/>
               </a:ext>
             </a:extLst>
           </p:cNvPr>
@@ -4023,7 +3961,7 @@
           <p:cNvPr id="11" name="table-cell-140-1-1">
             <a:extLst xmlns:a="http://schemas.openxmlformats.org/drawingml/2006/main">
               <a:ext uri="{FF2B5EF4-FFF2-40B4-BE49-F238E27FC236}">
-                <a16:creationId xmlns:a16="http://schemas.microsoft.com/office/drawing/2014/main" id="{3345CEBC-9529-493A-A46F-7EAB01EBD69B}"/>
+                <a16:creationId xmlns:a16="http://schemas.microsoft.com/office/drawing/2014/main" id="{117EEEDB-2E41-4980-92F3-AC95335EB87A}"/>
               </a:ext>
             </a:extLst>
           </p:cNvPr>
@@ -4056,7 +3994,7 @@
           <p:cNvPr id="12" name="table-text-140-1-1">
             <a:extLst xmlns:a="http://schemas.openxmlformats.org/drawingml/2006/main">
               <a:ext uri="{FF2B5EF4-FFF2-40B4-BE49-F238E27FC236}">
-                <a16:creationId xmlns:a16="http://schemas.microsoft.com/office/drawing/2014/main" id="{49D759A2-6388-426D-B866-6EFE21552D93}"/>
+                <a16:creationId xmlns:a16="http://schemas.microsoft.com/office/drawing/2014/main" id="{FCEF644A-565A-42BD-B678-E0D3F57CE53A}"/>
               </a:ext>
             </a:extLst>
           </p:cNvPr>
@@ -4118,7 +4056,7 @@
           <p:cNvPr id="13" name="table-cell-140-2-0">
             <a:extLst xmlns:a="http://schemas.openxmlformats.org/drawingml/2006/main">
               <a:ext uri="{FF2B5EF4-FFF2-40B4-BE49-F238E27FC236}">
-                <a16:creationId xmlns:a16="http://schemas.microsoft.com/office/drawing/2014/main" id="{0F66796C-57B5-4EA3-945A-3758EA2FF1AB}"/>
+                <a16:creationId xmlns:a16="http://schemas.microsoft.com/office/drawing/2014/main" id="{DD31D35B-8F6F-4B24-9944-CFDBCC30AAB9}"/>
               </a:ext>
             </a:extLst>
           </p:cNvPr>
@@ -4151,7 +4089,7 @@
           <p:cNvPr id="14" name="table-text-140-2-0">
             <a:extLst xmlns:a="http://schemas.openxmlformats.org/drawingml/2006/main">
               <a:ext uri="{FF2B5EF4-FFF2-40B4-BE49-F238E27FC236}">
-                <a16:creationId xmlns:a16="http://schemas.microsoft.com/office/drawing/2014/main" id="{910E6AEE-F14B-4C8B-848D-758763CE7517}"/>
+                <a16:creationId xmlns:a16="http://schemas.microsoft.com/office/drawing/2014/main" id="{D63041F6-C0FF-4C60-AA03-B74E608088E6}"/>
               </a:ext>
             </a:extLst>
           </p:cNvPr>
@@ -4213,7 +4151,7 @@
           <p:cNvPr id="15" name="table-cell-140-2-1">
             <a:extLst xmlns:a="http://schemas.openxmlformats.org/drawingml/2006/main">
               <a:ext uri="{FF2B5EF4-FFF2-40B4-BE49-F238E27FC236}">
-                <a16:creationId xmlns:a16="http://schemas.microsoft.com/office/drawing/2014/main" id="{9F85ED77-9AA9-4281-AEBA-0A2D27A72D24}"/>
+                <a16:creationId xmlns:a16="http://schemas.microsoft.com/office/drawing/2014/main" id="{E17A2857-834D-4CDD-AE30-8D6358ACD7D6}"/>
               </a:ext>
             </a:extLst>
           </p:cNvPr>
@@ -4246,7 +4184,7 @@
           <p:cNvPr id="16" name="table-text-140-2-1">
             <a:extLst xmlns:a="http://schemas.openxmlformats.org/drawingml/2006/main">
               <a:ext uri="{FF2B5EF4-FFF2-40B4-BE49-F238E27FC236}">
-                <a16:creationId xmlns:a16="http://schemas.microsoft.com/office/drawing/2014/main" id="{64430B27-FF0A-43EA-BE62-0D61A444553E}"/>
+                <a16:creationId xmlns:a16="http://schemas.microsoft.com/office/drawing/2014/main" id="{1348001F-B2E4-48AD-8E87-933C00E481D2}"/>
               </a:ext>
             </a:extLst>
           </p:cNvPr>
@@ -4308,7 +4246,7 @@
           <p:cNvPr id="17" name="table-cell-140-3-0">
             <a:extLst xmlns:a="http://schemas.openxmlformats.org/drawingml/2006/main">
               <a:ext uri="{FF2B5EF4-FFF2-40B4-BE49-F238E27FC236}">
-                <a16:creationId xmlns:a16="http://schemas.microsoft.com/office/drawing/2014/main" id="{DD466924-6DB3-4D5A-AD2B-7ED759341671}"/>
+                <a16:creationId xmlns:a16="http://schemas.microsoft.com/office/drawing/2014/main" id="{96B35C03-B7B4-491F-A223-C52B1E714941}"/>
               </a:ext>
             </a:extLst>
           </p:cNvPr>
@@ -4341,7 +4279,7 @@
           <p:cNvPr id="18" name="table-text-140-3-0">
             <a:extLst xmlns:a="http://schemas.openxmlformats.org/drawingml/2006/main">
               <a:ext uri="{FF2B5EF4-FFF2-40B4-BE49-F238E27FC236}">
-                <a16:creationId xmlns:a16="http://schemas.microsoft.com/office/drawing/2014/main" id="{3FB74E18-7BE1-4802-9E4A-CB4E75174514}"/>
+                <a16:creationId xmlns:a16="http://schemas.microsoft.com/office/drawing/2014/main" id="{81D40971-D11C-449D-8AE5-462D49D9EDAC}"/>
               </a:ext>
             </a:extLst>
           </p:cNvPr>
@@ -4403,7 +4341,7 @@
           <p:cNvPr id="19" name="table-cell-140-3-1">
             <a:extLst xmlns:a="http://schemas.openxmlformats.org/drawingml/2006/main">
               <a:ext uri="{FF2B5EF4-FFF2-40B4-BE49-F238E27FC236}">
-                <a16:creationId xmlns:a16="http://schemas.microsoft.com/office/drawing/2014/main" id="{A441F087-279B-48FF-9244-9EE6197F8A8C}"/>
+                <a16:creationId xmlns:a16="http://schemas.microsoft.com/office/drawing/2014/main" id="{4BECD7A1-8BD5-4B46-BFBB-05ACCED83016}"/>
               </a:ext>
             </a:extLst>
           </p:cNvPr>
@@ -4436,7 +4374,7 @@
           <p:cNvPr id="20" name="table-text-140-3-1">
             <a:extLst xmlns:a="http://schemas.openxmlformats.org/drawingml/2006/main">
               <a:ext uri="{FF2B5EF4-FFF2-40B4-BE49-F238E27FC236}">
-                <a16:creationId xmlns:a16="http://schemas.microsoft.com/office/drawing/2014/main" id="{7249C5C6-E652-40AA-880C-95126C3B9087}"/>
+                <a16:creationId xmlns:a16="http://schemas.microsoft.com/office/drawing/2014/main" id="{38AC1BA7-8C92-49E0-B1AE-A50831DEF0DC}"/>
               </a:ext>
             </a:extLst>
           </p:cNvPr>
@@ -4498,7 +4436,7 @@
           <p:cNvPr id="21" name="table-cell-140-4-0">
             <a:extLst xmlns:a="http://schemas.openxmlformats.org/drawingml/2006/main">
               <a:ext uri="{FF2B5EF4-FFF2-40B4-BE49-F238E27FC236}">
-                <a16:creationId xmlns:a16="http://schemas.microsoft.com/office/drawing/2014/main" id="{B8E35C6E-B423-4721-9012-51869BB412C7}"/>
+                <a16:creationId xmlns:a16="http://schemas.microsoft.com/office/drawing/2014/main" id="{E4FEA142-B1C5-45F1-A19C-B37C4D8D2706}"/>
               </a:ext>
             </a:extLst>
           </p:cNvPr>
@@ -4531,7 +4469,7 @@
           <p:cNvPr id="22" name="table-text-140-4-0">
             <a:extLst xmlns:a="http://schemas.openxmlformats.org/drawingml/2006/main">
               <a:ext uri="{FF2B5EF4-FFF2-40B4-BE49-F238E27FC236}">
-                <a16:creationId xmlns:a16="http://schemas.microsoft.com/office/drawing/2014/main" id="{1038366D-2D22-4522-8434-E8DB319FE6AC}"/>
+                <a16:creationId xmlns:a16="http://schemas.microsoft.com/office/drawing/2014/main" id="{2FDF3A9B-4BFE-4EC4-BAC2-D534A6D7ADA8}"/>
               </a:ext>
             </a:extLst>
           </p:cNvPr>
@@ -4593,7 +4531,7 @@
           <p:cNvPr id="23" name="table-cell-140-4-1">
             <a:extLst xmlns:a="http://schemas.openxmlformats.org/drawingml/2006/main">
               <a:ext uri="{FF2B5EF4-FFF2-40B4-BE49-F238E27FC236}">
-                <a16:creationId xmlns:a16="http://schemas.microsoft.com/office/drawing/2014/main" id="{C18EFE15-1640-4DE1-ABD6-A673CB834363}"/>
+                <a16:creationId xmlns:a16="http://schemas.microsoft.com/office/drawing/2014/main" id="{0BC8CE94-5E41-41FE-AB2C-D438927B4509}"/>
               </a:ext>
             </a:extLst>
           </p:cNvPr>
@@ -4626,7 +4564,7 @@
           <p:cNvPr id="24" name="table-text-140-4-1">
             <a:extLst xmlns:a="http://schemas.openxmlformats.org/drawingml/2006/main">
               <a:ext uri="{FF2B5EF4-FFF2-40B4-BE49-F238E27FC236}">
-                <a16:creationId xmlns:a16="http://schemas.microsoft.com/office/drawing/2014/main" id="{E6973943-411A-4354-A183-365DB2B23095}"/>
+                <a16:creationId xmlns:a16="http://schemas.microsoft.com/office/drawing/2014/main" id="{03E8FB47-5B7B-4EE1-913F-CEF992C9DB5F}"/>
               </a:ext>
             </a:extLst>
           </p:cNvPr>
@@ -4686,7 +4624,7 @@
     </p:spTree>
     <p:extLst>
       <p:ext uri="{BB962C8B-B14F-4D97-AF65-F5344CB8AC3E}">
-        <p14:creationId xmlns:p14="http://schemas.microsoft.com/office/powerpoint/2010/main" val="1608344639"/>
+        <p14:creationId xmlns:p14="http://schemas.microsoft.com/office/powerpoint/2010/main" val="1172768387"/>
       </p:ext>
     </p:extLst>
   </p:cSld>
@@ -4717,7 +4655,7 @@
           <p:cNvPr id="28" name="running-label">
             <a:extLst xmlns:a="http://schemas.openxmlformats.org/drawingml/2006/main">
               <a:ext uri="{FF2B5EF4-FFF2-40B4-BE49-F238E27FC236}">
-                <a16:creationId xmlns:a16="http://schemas.microsoft.com/office/drawing/2014/main" id="{B984E977-841B-4662-9CDF-F55C68913727}"/>
+                <a16:creationId xmlns:a16="http://schemas.microsoft.com/office/drawing/2014/main" id="{6F7FE889-B874-4C45-BB8F-91C8BFCD4DC0}"/>
               </a:ext>
             </a:extLst>
           </p:cNvPr>
@@ -4779,7 +4717,7 @@
           <p:cNvPr id="2" name="page-number">
             <a:extLst xmlns:a="http://schemas.openxmlformats.org/drawingml/2006/main">
               <a:ext uri="{FF2B5EF4-FFF2-40B4-BE49-F238E27FC236}">
-                <a16:creationId xmlns:a16="http://schemas.microsoft.com/office/drawing/2014/main" id="{FABE1CD9-682A-49ED-860E-6A85EE1586AC}"/>
+                <a16:creationId xmlns:a16="http://schemas.microsoft.com/office/drawing/2014/main" id="{91B74107-C307-4457-94EF-142837D8593D}"/>
               </a:ext>
             </a:extLst>
           </p:cNvPr>
@@ -4841,7 +4779,7 @@
           <p:cNvPr id="3" name="header-rule">
             <a:extLst xmlns:a="http://schemas.openxmlformats.org/drawingml/2006/main">
               <a:ext uri="{FF2B5EF4-FFF2-40B4-BE49-F238E27FC236}">
-                <a16:creationId xmlns:a16="http://schemas.microsoft.com/office/drawing/2014/main" id="{F45C9762-1693-45EA-BAC9-6A8F40D4E298}"/>
+                <a16:creationId xmlns:a16="http://schemas.microsoft.com/office/drawing/2014/main" id="{2193F4FF-133C-4B72-ACF1-923D1143B9F4}"/>
               </a:ext>
             </a:extLst>
           </p:cNvPr>
@@ -4872,7 +4810,7 @@
           <p:cNvPr id="4" name="slide-title">
             <a:extLst xmlns:a="http://schemas.openxmlformats.org/drawingml/2006/main">
               <a:ext uri="{FF2B5EF4-FFF2-40B4-BE49-F238E27FC236}">
-                <a16:creationId xmlns:a16="http://schemas.microsoft.com/office/drawing/2014/main" id="{3F51FA50-DC1B-4B6A-8F77-CDC33329CB68}"/>
+                <a16:creationId xmlns:a16="http://schemas.microsoft.com/office/drawing/2014/main" id="{452A12B2-69A3-4FDD-9A2A-4CDC4521EB29}"/>
               </a:ext>
             </a:extLst>
           </p:cNvPr>
@@ -4934,7 +4872,7 @@
           <p:cNvPr id="5" name="paragraph-140">
             <a:extLst xmlns:a="http://schemas.openxmlformats.org/drawingml/2006/main">
               <a:ext uri="{FF2B5EF4-FFF2-40B4-BE49-F238E27FC236}">
-                <a16:creationId xmlns:a16="http://schemas.microsoft.com/office/drawing/2014/main" id="{0CEABB45-43AD-4579-A39E-DE7A819BE20E}"/>
+                <a16:creationId xmlns:a16="http://schemas.microsoft.com/office/drawing/2014/main" id="{527D3347-219E-4732-9AB3-8EEB1C719369}"/>
               </a:ext>
             </a:extLst>
           </p:cNvPr>
@@ -5000,7 +4938,7 @@
           <p:nvPr/>
         </p:nvPicPr>
         <p:blipFill>
-          <a:blip xmlns:r="http://schemas.openxmlformats.org/officeDocument/2006/relationships" xmlns:a="http://schemas.openxmlformats.org/drawingml/2006/main" r:embed="Re1fa09ebc8fa4e0d"/>
+          <a:blip xmlns:r="http://schemas.openxmlformats.org/officeDocument/2006/relationships" xmlns:a="http://schemas.openxmlformats.org/drawingml/2006/main" r:embed="Rfc258c40777f4c86"/>
           <a:stretch xmlns:a="http://schemas.openxmlformats.org/drawingml/2006/main"/>
         </p:blipFill>
         <p:spPr>
@@ -5020,7 +4958,7 @@
           <p:cNvPr id="7" name="image-caption-212.64">
             <a:extLst xmlns:a="http://schemas.openxmlformats.org/drawingml/2006/main">
               <a:ext uri="{FF2B5EF4-FFF2-40B4-BE49-F238E27FC236}">
-                <a16:creationId xmlns:a16="http://schemas.microsoft.com/office/drawing/2014/main" id="{201097C3-47F8-47EB-A171-A5682CC3CFD0}"/>
+                <a16:creationId xmlns:a16="http://schemas.microsoft.com/office/drawing/2014/main" id="{B42CD1B8-C368-4645-B48F-DD1DF36769CE}"/>
               </a:ext>
             </a:extLst>
           </p:cNvPr>
@@ -5082,7 +5020,7 @@
           <p:cNvPr id="8" name="table-cell-596.64-0-0">
             <a:extLst xmlns:a="http://schemas.openxmlformats.org/drawingml/2006/main">
               <a:ext uri="{FF2B5EF4-FFF2-40B4-BE49-F238E27FC236}">
-                <a16:creationId xmlns:a16="http://schemas.microsoft.com/office/drawing/2014/main" id="{8BFE894C-1F45-4B8A-B756-09932ECF6578}"/>
+                <a16:creationId xmlns:a16="http://schemas.microsoft.com/office/drawing/2014/main" id="{3B94C196-887B-43B3-A03C-785B6BB487E9}"/>
               </a:ext>
             </a:extLst>
           </p:cNvPr>
@@ -5115,7 +5053,7 @@
           <p:cNvPr id="9" name="table-text-596.64-0-0">
             <a:extLst xmlns:a="http://schemas.openxmlformats.org/drawingml/2006/main">
               <a:ext uri="{FF2B5EF4-FFF2-40B4-BE49-F238E27FC236}">
-                <a16:creationId xmlns:a16="http://schemas.microsoft.com/office/drawing/2014/main" id="{502DA039-FA4C-48E2-B3B1-F18E8ABC1F3C}"/>
+                <a16:creationId xmlns:a16="http://schemas.microsoft.com/office/drawing/2014/main" id="{CDC73385-F1D1-46AC-B163-D256C2055F9E}"/>
               </a:ext>
             </a:extLst>
           </p:cNvPr>
@@ -5177,7 +5115,7 @@
           <p:cNvPr id="10" name="table-cell-596.64-0-1">
             <a:extLst xmlns:a="http://schemas.openxmlformats.org/drawingml/2006/main">
               <a:ext uri="{FF2B5EF4-FFF2-40B4-BE49-F238E27FC236}">
-                <a16:creationId xmlns:a16="http://schemas.microsoft.com/office/drawing/2014/main" id="{AE85B7E5-511A-4724-BDA6-4B7E569CEDDD}"/>
+                <a16:creationId xmlns:a16="http://schemas.microsoft.com/office/drawing/2014/main" id="{38D31CF6-98E2-49A3-86EA-6D79CDF5F0F3}"/>
               </a:ext>
             </a:extLst>
           </p:cNvPr>
@@ -5210,7 +5148,7 @@
           <p:cNvPr id="11" name="table-text-596.64-0-1">
             <a:extLst xmlns:a="http://schemas.openxmlformats.org/drawingml/2006/main">
               <a:ext uri="{FF2B5EF4-FFF2-40B4-BE49-F238E27FC236}">
-                <a16:creationId xmlns:a16="http://schemas.microsoft.com/office/drawing/2014/main" id="{58593C2D-793E-4CB6-9361-34F6BA3C689E}"/>
+                <a16:creationId xmlns:a16="http://schemas.microsoft.com/office/drawing/2014/main" id="{B1ED4D95-5CE7-4DE6-8FF3-6CCF26EEC05B}"/>
               </a:ext>
             </a:extLst>
           </p:cNvPr>
@@ -5272,7 +5210,7 @@
           <p:cNvPr id="12" name="table-cell-596.64-1-0">
             <a:extLst xmlns:a="http://schemas.openxmlformats.org/drawingml/2006/main">
               <a:ext uri="{FF2B5EF4-FFF2-40B4-BE49-F238E27FC236}">
-                <a16:creationId xmlns:a16="http://schemas.microsoft.com/office/drawing/2014/main" id="{05C9543B-C120-4D0E-861A-7AB88D428FCB}"/>
+                <a16:creationId xmlns:a16="http://schemas.microsoft.com/office/drawing/2014/main" id="{FAE91728-DEC1-4339-BEE4-1266F45FC0B1}"/>
               </a:ext>
             </a:extLst>
           </p:cNvPr>
@@ -5305,7 +5243,7 @@
           <p:cNvPr id="13" name="table-text-596.64-1-0">
             <a:extLst xmlns:a="http://schemas.openxmlformats.org/drawingml/2006/main">
               <a:ext uri="{FF2B5EF4-FFF2-40B4-BE49-F238E27FC236}">
-                <a16:creationId xmlns:a16="http://schemas.microsoft.com/office/drawing/2014/main" id="{6F5E4A8B-485C-41EE-9A65-CE7C121E720E}"/>
+                <a16:creationId xmlns:a16="http://schemas.microsoft.com/office/drawing/2014/main" id="{7A4683FB-C3A4-4877-9417-BF26E30EBF7E}"/>
               </a:ext>
             </a:extLst>
           </p:cNvPr>
@@ -5367,7 +5305,7 @@
           <p:cNvPr id="14" name="table-cell-596.64-1-1">
             <a:extLst xmlns:a="http://schemas.openxmlformats.org/drawingml/2006/main">
               <a:ext uri="{FF2B5EF4-FFF2-40B4-BE49-F238E27FC236}">
-                <a16:creationId xmlns:a16="http://schemas.microsoft.com/office/drawing/2014/main" id="{B043B9FA-246F-4B64-8209-6660B5ACF741}"/>
+                <a16:creationId xmlns:a16="http://schemas.microsoft.com/office/drawing/2014/main" id="{C982B8F9-98C0-4EF7-BDEB-F13354959C43}"/>
               </a:ext>
             </a:extLst>
           </p:cNvPr>
@@ -5400,7 +5338,7 @@
           <p:cNvPr id="15" name="table-text-596.64-1-1">
             <a:extLst xmlns:a="http://schemas.openxmlformats.org/drawingml/2006/main">
               <a:ext uri="{FF2B5EF4-FFF2-40B4-BE49-F238E27FC236}">
-                <a16:creationId xmlns:a16="http://schemas.microsoft.com/office/drawing/2014/main" id="{ADA6AF23-6EB7-4426-98C6-2E4D23191564}"/>
+                <a16:creationId xmlns:a16="http://schemas.microsoft.com/office/drawing/2014/main" id="{94FEB157-3282-425B-916D-069625AE9B86}"/>
               </a:ext>
             </a:extLst>
           </p:cNvPr>
@@ -5462,7 +5400,7 @@
           <p:cNvPr id="16" name="table-cell-596.64-2-0">
             <a:extLst xmlns:a="http://schemas.openxmlformats.org/drawingml/2006/main">
               <a:ext uri="{FF2B5EF4-FFF2-40B4-BE49-F238E27FC236}">
-                <a16:creationId xmlns:a16="http://schemas.microsoft.com/office/drawing/2014/main" id="{AFCDFF80-102D-4F08-B9E2-B0B07C38950E}"/>
+                <a16:creationId xmlns:a16="http://schemas.microsoft.com/office/drawing/2014/main" id="{01AFEAAE-0956-40B4-A55F-A67245DB9057}"/>
               </a:ext>
             </a:extLst>
           </p:cNvPr>
@@ -5495,7 +5433,7 @@
           <p:cNvPr id="17" name="table-text-596.64-2-0">
             <a:extLst xmlns:a="http://schemas.openxmlformats.org/drawingml/2006/main">
               <a:ext uri="{FF2B5EF4-FFF2-40B4-BE49-F238E27FC236}">
-                <a16:creationId xmlns:a16="http://schemas.microsoft.com/office/drawing/2014/main" id="{ECAA6009-4A52-4107-B0AA-E81707C8F01B}"/>
+                <a16:creationId xmlns:a16="http://schemas.microsoft.com/office/drawing/2014/main" id="{6F086F18-2167-46C8-9CEC-9C278D5C9AB7}"/>
               </a:ext>
             </a:extLst>
           </p:cNvPr>
@@ -5557,7 +5495,7 @@
           <p:cNvPr id="18" name="table-cell-596.64-2-1">
             <a:extLst xmlns:a="http://schemas.openxmlformats.org/drawingml/2006/main">
               <a:ext uri="{FF2B5EF4-FFF2-40B4-BE49-F238E27FC236}">
-                <a16:creationId xmlns:a16="http://schemas.microsoft.com/office/drawing/2014/main" id="{66C348E0-4850-4150-8E40-CF8D4BFA6EAD}"/>
+                <a16:creationId xmlns:a16="http://schemas.microsoft.com/office/drawing/2014/main" id="{7424C1D2-91F9-4547-AB20-81D6D182E4D2}"/>
               </a:ext>
             </a:extLst>
           </p:cNvPr>
@@ -5590,7 +5528,7 @@
           <p:cNvPr id="19" name="table-text-596.64-2-1">
             <a:extLst xmlns:a="http://schemas.openxmlformats.org/drawingml/2006/main">
               <a:ext uri="{FF2B5EF4-FFF2-40B4-BE49-F238E27FC236}">
-                <a16:creationId xmlns:a16="http://schemas.microsoft.com/office/drawing/2014/main" id="{AAAE3DDC-31D7-4766-A666-5C781E3AA22C}"/>
+                <a16:creationId xmlns:a16="http://schemas.microsoft.com/office/drawing/2014/main" id="{1C8ACE7E-620F-4183-9077-0E9E5062831A}"/>
               </a:ext>
             </a:extLst>
           </p:cNvPr>
@@ -5652,7 +5590,7 @@
           <p:cNvPr id="20" name="table-cell-596.64-3-0">
             <a:extLst xmlns:a="http://schemas.openxmlformats.org/drawingml/2006/main">
               <a:ext uri="{FF2B5EF4-FFF2-40B4-BE49-F238E27FC236}">
-                <a16:creationId xmlns:a16="http://schemas.microsoft.com/office/drawing/2014/main" id="{29C725CD-7135-480D-A1C3-7FFD705DCC82}"/>
+                <a16:creationId xmlns:a16="http://schemas.microsoft.com/office/drawing/2014/main" id="{C941E46E-7735-4DA0-974C-F717F6C04635}"/>
               </a:ext>
             </a:extLst>
           </p:cNvPr>
@@ -5685,7 +5623,7 @@
           <p:cNvPr id="21" name="table-text-596.64-3-0">
             <a:extLst xmlns:a="http://schemas.openxmlformats.org/drawingml/2006/main">
               <a:ext uri="{FF2B5EF4-FFF2-40B4-BE49-F238E27FC236}">
-                <a16:creationId xmlns:a16="http://schemas.microsoft.com/office/drawing/2014/main" id="{CBF5201A-D866-47A2-BD19-829427AD5F58}"/>
+                <a16:creationId xmlns:a16="http://schemas.microsoft.com/office/drawing/2014/main" id="{3D4A9DEE-C595-4423-B7DE-082328A238ED}"/>
               </a:ext>
             </a:extLst>
           </p:cNvPr>
@@ -5747,7 +5685,7 @@
           <p:cNvPr id="22" name="table-cell-596.64-3-1">
             <a:extLst xmlns:a="http://schemas.openxmlformats.org/drawingml/2006/main">
               <a:ext uri="{FF2B5EF4-FFF2-40B4-BE49-F238E27FC236}">
-                <a16:creationId xmlns:a16="http://schemas.microsoft.com/office/drawing/2014/main" id="{665344B0-1ADB-4C7E-BC54-44AA5230B2D2}"/>
+                <a16:creationId xmlns:a16="http://schemas.microsoft.com/office/drawing/2014/main" id="{758F9FD1-F938-4211-B320-53695287A217}"/>
               </a:ext>
             </a:extLst>
           </p:cNvPr>
@@ -5780,7 +5718,7 @@
           <p:cNvPr id="23" name="table-text-596.64-3-1">
             <a:extLst xmlns:a="http://schemas.openxmlformats.org/drawingml/2006/main">
               <a:ext uri="{FF2B5EF4-FFF2-40B4-BE49-F238E27FC236}">
-                <a16:creationId xmlns:a16="http://schemas.microsoft.com/office/drawing/2014/main" id="{876F28F1-6D59-4B43-8736-991748298062}"/>
+                <a16:creationId xmlns:a16="http://schemas.microsoft.com/office/drawing/2014/main" id="{42692C8E-7F72-4BDE-B9B6-7CE33F30C7EF}"/>
               </a:ext>
             </a:extLst>
           </p:cNvPr>
@@ -5842,7 +5780,7 @@
           <p:cNvPr id="24" name="table-cell-596.64-4-0">
             <a:extLst xmlns:a="http://schemas.openxmlformats.org/drawingml/2006/main">
               <a:ext uri="{FF2B5EF4-FFF2-40B4-BE49-F238E27FC236}">
-                <a16:creationId xmlns:a16="http://schemas.microsoft.com/office/drawing/2014/main" id="{20C37673-FC82-490E-BC02-1682170CC2B7}"/>
+                <a16:creationId xmlns:a16="http://schemas.microsoft.com/office/drawing/2014/main" id="{18E5ADE9-D2DE-43D1-9259-FA6AA4C0042B}"/>
               </a:ext>
             </a:extLst>
           </p:cNvPr>
@@ -5875,7 +5813,7 @@
           <p:cNvPr id="25" name="table-text-596.64-4-0">
             <a:extLst xmlns:a="http://schemas.openxmlformats.org/drawingml/2006/main">
               <a:ext uri="{FF2B5EF4-FFF2-40B4-BE49-F238E27FC236}">
-                <a16:creationId xmlns:a16="http://schemas.microsoft.com/office/drawing/2014/main" id="{F3081EE3-FED9-479B-8E51-467F16CC0CB0}"/>
+                <a16:creationId xmlns:a16="http://schemas.microsoft.com/office/drawing/2014/main" id="{6819C956-35B3-4B5C-821F-145C71777FA2}"/>
               </a:ext>
             </a:extLst>
           </p:cNvPr>
@@ -5937,7 +5875,7 @@
           <p:cNvPr id="26" name="table-cell-596.64-4-1">
             <a:extLst xmlns:a="http://schemas.openxmlformats.org/drawingml/2006/main">
               <a:ext uri="{FF2B5EF4-FFF2-40B4-BE49-F238E27FC236}">
-                <a16:creationId xmlns:a16="http://schemas.microsoft.com/office/drawing/2014/main" id="{2110C325-4B58-4867-B3BF-8D54007DD10C}"/>
+                <a16:creationId xmlns:a16="http://schemas.microsoft.com/office/drawing/2014/main" id="{1DEA22FA-1C3F-4E37-8B6C-F70428941CFE}"/>
               </a:ext>
             </a:extLst>
           </p:cNvPr>
@@ -5970,7 +5908,7 @@
           <p:cNvPr id="27" name="table-text-596.64-4-1">
             <a:extLst xmlns:a="http://schemas.openxmlformats.org/drawingml/2006/main">
               <a:ext uri="{FF2B5EF4-FFF2-40B4-BE49-F238E27FC236}">
-                <a16:creationId xmlns:a16="http://schemas.microsoft.com/office/drawing/2014/main" id="{079ACBE9-4A24-4EF5-9EC4-07043BED8D7B}"/>
+                <a16:creationId xmlns:a16="http://schemas.microsoft.com/office/drawing/2014/main" id="{6EDDBC8F-CC56-46D6-A1A7-A91812E559CC}"/>
               </a:ext>
             </a:extLst>
           </p:cNvPr>
@@ -6030,7 +5968,7 @@
     </p:spTree>
     <p:extLst>
       <p:ext uri="{BB962C8B-B14F-4D97-AF65-F5344CB8AC3E}">
-        <p14:creationId xmlns:p14="http://schemas.microsoft.com/office/powerpoint/2010/main" val="119423051"/>
+        <p14:creationId xmlns:p14="http://schemas.microsoft.com/office/powerpoint/2010/main" val="1687427708"/>
       </p:ext>
     </p:extLst>
   </p:cSld>
@@ -6061,7 +5999,7 @@
           <p:cNvPr id="27" name="running-label">
             <a:extLst xmlns:a="http://schemas.openxmlformats.org/drawingml/2006/main">
               <a:ext uri="{FF2B5EF4-FFF2-40B4-BE49-F238E27FC236}">
-                <a16:creationId xmlns:a16="http://schemas.microsoft.com/office/drawing/2014/main" id="{ADEEE9A0-8686-4095-B988-B42803AD0F80}"/>
+                <a16:creationId xmlns:a16="http://schemas.microsoft.com/office/drawing/2014/main" id="{0A3CABA5-F18C-4C44-90B6-E095985AA6A5}"/>
               </a:ext>
             </a:extLst>
           </p:cNvPr>
@@ -6123,7 +6061,7 @@
           <p:cNvPr id="2" name="page-number">
             <a:extLst xmlns:a="http://schemas.openxmlformats.org/drawingml/2006/main">
               <a:ext uri="{FF2B5EF4-FFF2-40B4-BE49-F238E27FC236}">
-                <a16:creationId xmlns:a16="http://schemas.microsoft.com/office/drawing/2014/main" id="{8064BDA5-E00E-4402-8A54-74FE8386B001}"/>
+                <a16:creationId xmlns:a16="http://schemas.microsoft.com/office/drawing/2014/main" id="{92F63EB6-7004-4622-A9C7-ADF3F4A73A7B}"/>
               </a:ext>
             </a:extLst>
           </p:cNvPr>
@@ -6185,7 +6123,7 @@
           <p:cNvPr id="3" name="header-rule">
             <a:extLst xmlns:a="http://schemas.openxmlformats.org/drawingml/2006/main">
               <a:ext uri="{FF2B5EF4-FFF2-40B4-BE49-F238E27FC236}">
-                <a16:creationId xmlns:a16="http://schemas.microsoft.com/office/drawing/2014/main" id="{71D3AB29-DC4D-424B-AA14-C3662B956022}"/>
+                <a16:creationId xmlns:a16="http://schemas.microsoft.com/office/drawing/2014/main" id="{5052E62A-0EAE-43BB-B62B-D55AC3849BD8}"/>
               </a:ext>
             </a:extLst>
           </p:cNvPr>
@@ -6216,7 +6154,7 @@
           <p:cNvPr id="4" name="slide-title">
             <a:extLst xmlns:a="http://schemas.openxmlformats.org/drawingml/2006/main">
               <a:ext uri="{FF2B5EF4-FFF2-40B4-BE49-F238E27FC236}">
-                <a16:creationId xmlns:a16="http://schemas.microsoft.com/office/drawing/2014/main" id="{8467B32D-E652-4FBA-8086-C513AE54BDDD}"/>
+                <a16:creationId xmlns:a16="http://schemas.microsoft.com/office/drawing/2014/main" id="{FB8F02D9-8941-4C39-A71B-15BA63DEA263}"/>
               </a:ext>
             </a:extLst>
           </p:cNvPr>
@@ -6278,7 +6216,7 @@
           <p:cNvPr id="5" name="subheading-140">
             <a:extLst xmlns:a="http://schemas.openxmlformats.org/drawingml/2006/main">
               <a:ext uri="{FF2B5EF4-FFF2-40B4-BE49-F238E27FC236}">
-                <a16:creationId xmlns:a16="http://schemas.microsoft.com/office/drawing/2014/main" id="{465263AA-7E6B-41B7-B95D-74DAF64ABA9E}"/>
+                <a16:creationId xmlns:a16="http://schemas.microsoft.com/office/drawing/2014/main" id="{F08E893D-3B7D-42F0-ADD9-46C6B22C4DA7}"/>
               </a:ext>
             </a:extLst>
           </p:cNvPr>
@@ -6340,7 +6278,7 @@
           <p:cNvPr id="6" name="bullets-194">
             <a:extLst xmlns:a="http://schemas.openxmlformats.org/drawingml/2006/main">
               <a:ext uri="{FF2B5EF4-FFF2-40B4-BE49-F238E27FC236}">
-                <a16:creationId xmlns:a16="http://schemas.microsoft.com/office/drawing/2014/main" id="{862F70A6-7CE9-4E95-8BE2-BF1720AC3898}"/>
+                <a16:creationId xmlns:a16="http://schemas.microsoft.com/office/drawing/2014/main" id="{04B9A6C2-ABBD-4879-B337-F84403180AB7}"/>
               </a:ext>
             </a:extLst>
           </p:cNvPr>
@@ -6529,7 +6467,7 @@
           <p:nvPr/>
         </p:nvPicPr>
         <p:blipFill>
-          <a:blip xmlns:r="http://schemas.openxmlformats.org/officeDocument/2006/relationships" xmlns:a="http://schemas.openxmlformats.org/drawingml/2006/main" r:embed="R1adf2c451e3a45e7"/>
+          <a:blip xmlns:r="http://schemas.openxmlformats.org/officeDocument/2006/relationships" xmlns:a="http://schemas.openxmlformats.org/drawingml/2006/main" r:embed="Rd179475efcb44f43"/>
           <a:stretch xmlns:a="http://schemas.openxmlformats.org/drawingml/2006/main"/>
         </p:blipFill>
         <p:spPr>
@@ -6549,7 +6487,7 @@
           <p:cNvPr id="8" name="image-caption-417.92">
             <a:extLst xmlns:a="http://schemas.openxmlformats.org/drawingml/2006/main">
               <a:ext uri="{FF2B5EF4-FFF2-40B4-BE49-F238E27FC236}">
-                <a16:creationId xmlns:a16="http://schemas.microsoft.com/office/drawing/2014/main" id="{284B79E9-155D-4391-B4EC-8275194A9E58}"/>
+                <a16:creationId xmlns:a16="http://schemas.microsoft.com/office/drawing/2014/main" id="{8DF2D1C7-388D-41BB-8508-D7936035C7E0}"/>
               </a:ext>
             </a:extLst>
           </p:cNvPr>
@@ -6611,7 +6549,7 @@
           <p:cNvPr id="9" name="subheading-801.9200000000001">
             <a:extLst xmlns:a="http://schemas.openxmlformats.org/drawingml/2006/main">
               <a:ext uri="{FF2B5EF4-FFF2-40B4-BE49-F238E27FC236}">
-                <a16:creationId xmlns:a16="http://schemas.microsoft.com/office/drawing/2014/main" id="{FE0EC4D2-C169-4D2D-B842-4F9BF139577E}"/>
+                <a16:creationId xmlns:a16="http://schemas.microsoft.com/office/drawing/2014/main" id="{05BE9696-8242-426E-A7A0-E6AD97C61E17}"/>
               </a:ext>
             </a:extLst>
           </p:cNvPr>
@@ -6673,7 +6611,7 @@
           <p:cNvPr id="10" name="table-cell-855.9200000000001-0-0">
             <a:extLst xmlns:a="http://schemas.openxmlformats.org/drawingml/2006/main">
               <a:ext uri="{FF2B5EF4-FFF2-40B4-BE49-F238E27FC236}">
-                <a16:creationId xmlns:a16="http://schemas.microsoft.com/office/drawing/2014/main" id="{F4B485AC-C394-417B-BD94-72E7C3EA42C3}"/>
+                <a16:creationId xmlns:a16="http://schemas.microsoft.com/office/drawing/2014/main" id="{ACAC2B4E-CB25-4B7D-A91B-10C700984F39}"/>
               </a:ext>
             </a:extLst>
           </p:cNvPr>
@@ -6706,7 +6644,7 @@
           <p:cNvPr id="11" name="table-text-855.9200000000001-0-0">
             <a:extLst xmlns:a="http://schemas.openxmlformats.org/drawingml/2006/main">
               <a:ext uri="{FF2B5EF4-FFF2-40B4-BE49-F238E27FC236}">
-                <a16:creationId xmlns:a16="http://schemas.microsoft.com/office/drawing/2014/main" id="{8EC836F3-E222-4BB5-BEE2-5256C2830048}"/>
+                <a16:creationId xmlns:a16="http://schemas.microsoft.com/office/drawing/2014/main" id="{13358B33-53D5-4BA5-8B14-8FF8670C462A}"/>
               </a:ext>
             </a:extLst>
           </p:cNvPr>
@@ -6768,7 +6706,7 @@
           <p:cNvPr id="12" name="table-cell-855.9200000000001-0-1">
             <a:extLst xmlns:a="http://schemas.openxmlformats.org/drawingml/2006/main">
               <a:ext uri="{FF2B5EF4-FFF2-40B4-BE49-F238E27FC236}">
-                <a16:creationId xmlns:a16="http://schemas.microsoft.com/office/drawing/2014/main" id="{E85C1CE4-A208-4889-B069-88568D939DE7}"/>
+                <a16:creationId xmlns:a16="http://schemas.microsoft.com/office/drawing/2014/main" id="{E90E3C4D-2FBC-474D-9579-C21E36E630B0}"/>
               </a:ext>
             </a:extLst>
           </p:cNvPr>
@@ -6801,7 +6739,7 @@
           <p:cNvPr id="13" name="table-text-855.9200000000001-0-1">
             <a:extLst xmlns:a="http://schemas.openxmlformats.org/drawingml/2006/main">
               <a:ext uri="{FF2B5EF4-FFF2-40B4-BE49-F238E27FC236}">
-                <a16:creationId xmlns:a16="http://schemas.microsoft.com/office/drawing/2014/main" id="{58F89C5A-7EDE-4242-8A5F-1DE20AF533B2}"/>
+                <a16:creationId xmlns:a16="http://schemas.microsoft.com/office/drawing/2014/main" id="{4AC94B15-178E-4DD0-A2F5-25EC919A2FFA}"/>
               </a:ext>
             </a:extLst>
           </p:cNvPr>
@@ -6863,7 +6801,7 @@
           <p:cNvPr id="14" name="table-cell-855.9200000000001-0-2">
             <a:extLst xmlns:a="http://schemas.openxmlformats.org/drawingml/2006/main">
               <a:ext uri="{FF2B5EF4-FFF2-40B4-BE49-F238E27FC236}">
-                <a16:creationId xmlns:a16="http://schemas.microsoft.com/office/drawing/2014/main" id="{B5121344-BE20-4D81-A773-B4A211233C7D}"/>
+                <a16:creationId xmlns:a16="http://schemas.microsoft.com/office/drawing/2014/main" id="{5DACD40E-F5C4-4D2D-B619-417B82E052F1}"/>
               </a:ext>
             </a:extLst>
           </p:cNvPr>
@@ -6896,7 +6834,7 @@
           <p:cNvPr id="15" name="table-text-855.9200000000001-0-2">
             <a:extLst xmlns:a="http://schemas.openxmlformats.org/drawingml/2006/main">
               <a:ext uri="{FF2B5EF4-FFF2-40B4-BE49-F238E27FC236}">
-                <a16:creationId xmlns:a16="http://schemas.microsoft.com/office/drawing/2014/main" id="{1217213A-6229-4E56-A3BE-C62838A0726C}"/>
+                <a16:creationId xmlns:a16="http://schemas.microsoft.com/office/drawing/2014/main" id="{132B7857-3C6B-484C-9825-70774F16788D}"/>
               </a:ext>
             </a:extLst>
           </p:cNvPr>
@@ -6958,7 +6896,7 @@
           <p:cNvPr id="16" name="table-cell-855.9200000000001-0-3">
             <a:extLst xmlns:a="http://schemas.openxmlformats.org/drawingml/2006/main">
               <a:ext uri="{FF2B5EF4-FFF2-40B4-BE49-F238E27FC236}">
-                <a16:creationId xmlns:a16="http://schemas.microsoft.com/office/drawing/2014/main" id="{90EF0A89-6AC9-4BB7-B837-CEF80192527F}"/>
+                <a16:creationId xmlns:a16="http://schemas.microsoft.com/office/drawing/2014/main" id="{E50777CD-5E8B-4F8E-814B-01E9ED4D3DED}"/>
               </a:ext>
             </a:extLst>
           </p:cNvPr>
@@ -6991,7 +6929,7 @@
           <p:cNvPr id="17" name="table-text-855.9200000000001-0-3">
             <a:extLst xmlns:a="http://schemas.openxmlformats.org/drawingml/2006/main">
               <a:ext uri="{FF2B5EF4-FFF2-40B4-BE49-F238E27FC236}">
-                <a16:creationId xmlns:a16="http://schemas.microsoft.com/office/drawing/2014/main" id="{767B8A21-5C16-4618-8F98-D0356064E9F8}"/>
+                <a16:creationId xmlns:a16="http://schemas.microsoft.com/office/drawing/2014/main" id="{A4E7E996-72ED-435D-81A3-FF95FCCAA1C4}"/>
               </a:ext>
             </a:extLst>
           </p:cNvPr>
@@ -7053,7 +6991,7 @@
           <p:cNvPr id="18" name="table-cell-855.9200000000001-1-0">
             <a:extLst xmlns:a="http://schemas.openxmlformats.org/drawingml/2006/main">
               <a:ext uri="{FF2B5EF4-FFF2-40B4-BE49-F238E27FC236}">
-                <a16:creationId xmlns:a16="http://schemas.microsoft.com/office/drawing/2014/main" id="{AA07414E-7A74-4AD1-967D-959F0495447A}"/>
+                <a16:creationId xmlns:a16="http://schemas.microsoft.com/office/drawing/2014/main" id="{615933B2-0BC0-4355-9E10-2C6CC42CBD3C}"/>
               </a:ext>
             </a:extLst>
           </p:cNvPr>
@@ -7086,7 +7024,7 @@
           <p:cNvPr id="19" name="table-text-855.9200000000001-1-0">
             <a:extLst xmlns:a="http://schemas.openxmlformats.org/drawingml/2006/main">
               <a:ext uri="{FF2B5EF4-FFF2-40B4-BE49-F238E27FC236}">
-                <a16:creationId xmlns:a16="http://schemas.microsoft.com/office/drawing/2014/main" id="{3D94912D-4971-41A8-8CED-560F309A9F31}"/>
+                <a16:creationId xmlns:a16="http://schemas.microsoft.com/office/drawing/2014/main" id="{429E6489-F4D0-4AB9-97B2-EB5171A83764}"/>
               </a:ext>
             </a:extLst>
           </p:cNvPr>
@@ -7148,7 +7086,7 @@
           <p:cNvPr id="20" name="table-cell-855.9200000000001-1-1">
             <a:extLst xmlns:a="http://schemas.openxmlformats.org/drawingml/2006/main">
               <a:ext uri="{FF2B5EF4-FFF2-40B4-BE49-F238E27FC236}">
-                <a16:creationId xmlns:a16="http://schemas.microsoft.com/office/drawing/2014/main" id="{6A97DDB4-4ADD-4C38-A786-74D28CDC9C16}"/>
+                <a16:creationId xmlns:a16="http://schemas.microsoft.com/office/drawing/2014/main" id="{A1960285-E2B2-45C9-A7F1-DA7F9D806671}"/>
               </a:ext>
             </a:extLst>
           </p:cNvPr>
@@ -7181,7 +7119,7 @@
           <p:cNvPr id="21" name="table-text-855.9200000000001-1-1">
             <a:extLst xmlns:a="http://schemas.openxmlformats.org/drawingml/2006/main">
               <a:ext uri="{FF2B5EF4-FFF2-40B4-BE49-F238E27FC236}">
-                <a16:creationId xmlns:a16="http://schemas.microsoft.com/office/drawing/2014/main" id="{D4248CB7-DCB2-4D3E-A4DA-FA08AE95FFA0}"/>
+                <a16:creationId xmlns:a16="http://schemas.microsoft.com/office/drawing/2014/main" id="{E892F79A-CAD8-4EE0-99E3-81CE97F5C02A}"/>
               </a:ext>
             </a:extLst>
           </p:cNvPr>
@@ -7243,7 +7181,7 @@
           <p:cNvPr id="22" name="table-cell-855.9200000000001-1-2">
             <a:extLst xmlns:a="http://schemas.openxmlformats.org/drawingml/2006/main">
               <a:ext uri="{FF2B5EF4-FFF2-40B4-BE49-F238E27FC236}">
-                <a16:creationId xmlns:a16="http://schemas.microsoft.com/office/drawing/2014/main" id="{333A67D0-F7A7-4161-B663-837E543720B6}"/>
+                <a16:creationId xmlns:a16="http://schemas.microsoft.com/office/drawing/2014/main" id="{54E803A2-4492-4E1B-82B1-1FC1762D1609}"/>
               </a:ext>
             </a:extLst>
           </p:cNvPr>
@@ -7276,7 +7214,7 @@
           <p:cNvPr id="23" name="table-text-855.9200000000001-1-2">
             <a:extLst xmlns:a="http://schemas.openxmlformats.org/drawingml/2006/main">
               <a:ext uri="{FF2B5EF4-FFF2-40B4-BE49-F238E27FC236}">
-                <a16:creationId xmlns:a16="http://schemas.microsoft.com/office/drawing/2014/main" id="{775CE437-593A-4E0C-9DDF-B286747E2DD7}"/>
+                <a16:creationId xmlns:a16="http://schemas.microsoft.com/office/drawing/2014/main" id="{E90863DC-938D-4AE9-9114-24A8BD212231}"/>
               </a:ext>
             </a:extLst>
           </p:cNvPr>
@@ -7338,7 +7276,7 @@
           <p:cNvPr id="24" name="table-cell-855.9200000000001-1-3">
             <a:extLst xmlns:a="http://schemas.openxmlformats.org/drawingml/2006/main">
               <a:ext uri="{FF2B5EF4-FFF2-40B4-BE49-F238E27FC236}">
-                <a16:creationId xmlns:a16="http://schemas.microsoft.com/office/drawing/2014/main" id="{56480564-D4AE-4BDB-84AE-BE892D6C31ED}"/>
+                <a16:creationId xmlns:a16="http://schemas.microsoft.com/office/drawing/2014/main" id="{3B86EC11-7461-4DDC-B832-42EEE200E3D0}"/>
               </a:ext>
             </a:extLst>
           </p:cNvPr>
@@ -7371,7 +7309,7 @@
           <p:cNvPr id="25" name="table-text-855.9200000000001-1-3">
             <a:extLst xmlns:a="http://schemas.openxmlformats.org/drawingml/2006/main">
               <a:ext uri="{FF2B5EF4-FFF2-40B4-BE49-F238E27FC236}">
-                <a16:creationId xmlns:a16="http://schemas.microsoft.com/office/drawing/2014/main" id="{00B5B9A6-364F-4808-8588-2748F52B091D}"/>
+                <a16:creationId xmlns:a16="http://schemas.microsoft.com/office/drawing/2014/main" id="{DB36D539-BF50-42EF-8AAB-CEAADC3B5BAE}"/>
               </a:ext>
             </a:extLst>
           </p:cNvPr>
@@ -7433,7 +7371,7 @@
           <p:cNvPr id="26" name="paragraph-973.0200000000001">
             <a:extLst xmlns:a="http://schemas.openxmlformats.org/drawingml/2006/main">
               <a:ext uri="{FF2B5EF4-FFF2-40B4-BE49-F238E27FC236}">
-                <a16:creationId xmlns:a16="http://schemas.microsoft.com/office/drawing/2014/main" id="{B5069237-0968-4DC7-AAC5-A97FD0AA8BBA}"/>
+                <a16:creationId xmlns:a16="http://schemas.microsoft.com/office/drawing/2014/main" id="{6A78F7C4-17B0-401C-B7D5-9FB5618F52AA}"/>
               </a:ext>
             </a:extLst>
           </p:cNvPr>
@@ -7493,7 +7431,7 @@
     </p:spTree>
     <p:extLst>
       <p:ext uri="{BB962C8B-B14F-4D97-AF65-F5344CB8AC3E}">
-        <p14:creationId xmlns:p14="http://schemas.microsoft.com/office/powerpoint/2010/main" val="1629849629"/>
+        <p14:creationId xmlns:p14="http://schemas.microsoft.com/office/powerpoint/2010/main" val="1680825391"/>
       </p:ext>
     </p:extLst>
   </p:cSld>
@@ -7524,7 +7462,7 @@
           <p:cNvPr id="38" name="running-label">
             <a:extLst xmlns:a="http://schemas.openxmlformats.org/drawingml/2006/main">
               <a:ext uri="{FF2B5EF4-FFF2-40B4-BE49-F238E27FC236}">
-                <a16:creationId xmlns:a16="http://schemas.microsoft.com/office/drawing/2014/main" id="{ACB6F05E-6B1F-4973-8C1B-E35514CE1CC0}"/>
+                <a16:creationId xmlns:a16="http://schemas.microsoft.com/office/drawing/2014/main" id="{D21CBFCD-5C89-41CC-AA31-303EDBE67BF4}"/>
               </a:ext>
             </a:extLst>
           </p:cNvPr>
@@ -7586,7 +7524,7 @@
           <p:cNvPr id="2" name="page-number">
             <a:extLst xmlns:a="http://schemas.openxmlformats.org/drawingml/2006/main">
               <a:ext uri="{FF2B5EF4-FFF2-40B4-BE49-F238E27FC236}">
-                <a16:creationId xmlns:a16="http://schemas.microsoft.com/office/drawing/2014/main" id="{063CD49D-98E9-46F7-9F9F-92F0F97DE692}"/>
+                <a16:creationId xmlns:a16="http://schemas.microsoft.com/office/drawing/2014/main" id="{499E85A3-3A1B-4AAD-93CC-85C5A755DF99}"/>
               </a:ext>
             </a:extLst>
           </p:cNvPr>
@@ -7648,7 +7586,7 @@
           <p:cNvPr id="3" name="header-rule">
             <a:extLst xmlns:a="http://schemas.openxmlformats.org/drawingml/2006/main">
               <a:ext uri="{FF2B5EF4-FFF2-40B4-BE49-F238E27FC236}">
-                <a16:creationId xmlns:a16="http://schemas.microsoft.com/office/drawing/2014/main" id="{5092235D-8C39-43E7-921F-4D5CCFB6396E}"/>
+                <a16:creationId xmlns:a16="http://schemas.microsoft.com/office/drawing/2014/main" id="{18A0DA0A-F15F-4AA5-95E4-8196ED82FC2C}"/>
               </a:ext>
             </a:extLst>
           </p:cNvPr>
@@ -7679,7 +7617,7 @@
           <p:cNvPr id="4" name="slide-title">
             <a:extLst xmlns:a="http://schemas.openxmlformats.org/drawingml/2006/main">
               <a:ext uri="{FF2B5EF4-FFF2-40B4-BE49-F238E27FC236}">
-                <a16:creationId xmlns:a16="http://schemas.microsoft.com/office/drawing/2014/main" id="{54E526B8-A53B-404B-A00E-D027E646596D}"/>
+                <a16:creationId xmlns:a16="http://schemas.microsoft.com/office/drawing/2014/main" id="{66C5E204-7944-4CFE-9F12-3DA54E7499CB}"/>
               </a:ext>
             </a:extLst>
           </p:cNvPr>
@@ -7741,7 +7679,7 @@
           <p:cNvPr id="5" name="subheading-140">
             <a:extLst xmlns:a="http://schemas.openxmlformats.org/drawingml/2006/main">
               <a:ext uri="{FF2B5EF4-FFF2-40B4-BE49-F238E27FC236}">
-                <a16:creationId xmlns:a16="http://schemas.microsoft.com/office/drawing/2014/main" id="{F4C0EF76-C388-40F3-B66E-4405F55A1631}"/>
+                <a16:creationId xmlns:a16="http://schemas.microsoft.com/office/drawing/2014/main" id="{BE49AC7F-99C3-41EB-91F3-D749798CE0DF}"/>
               </a:ext>
             </a:extLst>
           </p:cNvPr>
@@ -7803,7 +7741,7 @@
           <p:cNvPr id="6" name="table-cell-194-0-0">
             <a:extLst xmlns:a="http://schemas.openxmlformats.org/drawingml/2006/main">
               <a:ext uri="{FF2B5EF4-FFF2-40B4-BE49-F238E27FC236}">
-                <a16:creationId xmlns:a16="http://schemas.microsoft.com/office/drawing/2014/main" id="{02865826-202A-43D9-82D9-AD133EFE31CD}"/>
+                <a16:creationId xmlns:a16="http://schemas.microsoft.com/office/drawing/2014/main" id="{8CF7C067-6D89-4A29-BB80-51ED597058E5}"/>
               </a:ext>
             </a:extLst>
           </p:cNvPr>
@@ -7836,7 +7774,7 @@
           <p:cNvPr id="7" name="table-text-194-0-0">
             <a:extLst xmlns:a="http://schemas.openxmlformats.org/drawingml/2006/main">
               <a:ext uri="{FF2B5EF4-FFF2-40B4-BE49-F238E27FC236}">
-                <a16:creationId xmlns:a16="http://schemas.microsoft.com/office/drawing/2014/main" id="{2E0E157B-EB46-4F42-9353-B183FBF47343}"/>
+                <a16:creationId xmlns:a16="http://schemas.microsoft.com/office/drawing/2014/main" id="{0B5801B3-7E88-4756-BA74-2173E3A53BC1}"/>
               </a:ext>
             </a:extLst>
           </p:cNvPr>
@@ -7898,7 +7836,7 @@
           <p:cNvPr id="8" name="table-cell-194-0-1">
             <a:extLst xmlns:a="http://schemas.openxmlformats.org/drawingml/2006/main">
               <a:ext uri="{FF2B5EF4-FFF2-40B4-BE49-F238E27FC236}">
-                <a16:creationId xmlns:a16="http://schemas.microsoft.com/office/drawing/2014/main" id="{61E2EEBF-1118-43C3-96FF-318F70734EE8}"/>
+                <a16:creationId xmlns:a16="http://schemas.microsoft.com/office/drawing/2014/main" id="{C17524F3-4418-4D5E-A4D8-9F306DD174CA}"/>
               </a:ext>
             </a:extLst>
           </p:cNvPr>
@@ -7931,7 +7869,7 @@
           <p:cNvPr id="9" name="table-text-194-0-1">
             <a:extLst xmlns:a="http://schemas.openxmlformats.org/drawingml/2006/main">
               <a:ext uri="{FF2B5EF4-FFF2-40B4-BE49-F238E27FC236}">
-                <a16:creationId xmlns:a16="http://schemas.microsoft.com/office/drawing/2014/main" id="{30559D56-8413-4288-9F9F-19F4871E0E96}"/>
+                <a16:creationId xmlns:a16="http://schemas.microsoft.com/office/drawing/2014/main" id="{E40CBDED-A0F1-48A7-8990-163BE2D02DF7}"/>
               </a:ext>
             </a:extLst>
           </p:cNvPr>
@@ -7993,7 +7931,7 @@
           <p:cNvPr id="10" name="table-cell-194-0-2">
             <a:extLst xmlns:a="http://schemas.openxmlformats.org/drawingml/2006/main">
               <a:ext uri="{FF2B5EF4-FFF2-40B4-BE49-F238E27FC236}">
-                <a16:creationId xmlns:a16="http://schemas.microsoft.com/office/drawing/2014/main" id="{D452000A-A7A8-4ACA-8A59-DC4BA904ADA9}"/>
+                <a16:creationId xmlns:a16="http://schemas.microsoft.com/office/drawing/2014/main" id="{8B0A7A1D-01EC-45AF-8022-CF3791DC89F7}"/>
               </a:ext>
             </a:extLst>
           </p:cNvPr>
@@ -8026,7 +7964,7 @@
           <p:cNvPr id="11" name="table-text-194-0-2">
             <a:extLst xmlns:a="http://schemas.openxmlformats.org/drawingml/2006/main">
               <a:ext uri="{FF2B5EF4-FFF2-40B4-BE49-F238E27FC236}">
-                <a16:creationId xmlns:a16="http://schemas.microsoft.com/office/drawing/2014/main" id="{F7891835-68AA-44A8-B65F-7D0F26ACD9CF}"/>
+                <a16:creationId xmlns:a16="http://schemas.microsoft.com/office/drawing/2014/main" id="{AF2E921C-0F55-4748-8DA8-518B4F5A1789}"/>
               </a:ext>
             </a:extLst>
           </p:cNvPr>
@@ -8088,7 +8026,7 @@
           <p:cNvPr id="12" name="table-cell-194-1-0">
             <a:extLst xmlns:a="http://schemas.openxmlformats.org/drawingml/2006/main">
               <a:ext uri="{FF2B5EF4-FFF2-40B4-BE49-F238E27FC236}">
-                <a16:creationId xmlns:a16="http://schemas.microsoft.com/office/drawing/2014/main" id="{D739202B-4BAD-4386-8610-47908B27FB91}"/>
+                <a16:creationId xmlns:a16="http://schemas.microsoft.com/office/drawing/2014/main" id="{BFCE20E9-73CE-4806-86D4-6D7EB532F14F}"/>
               </a:ext>
             </a:extLst>
           </p:cNvPr>
@@ -8121,7 +8059,7 @@
           <p:cNvPr id="13" name="table-text-194-1-0">
             <a:extLst xmlns:a="http://schemas.openxmlformats.org/drawingml/2006/main">
               <a:ext uri="{FF2B5EF4-FFF2-40B4-BE49-F238E27FC236}">
-                <a16:creationId xmlns:a16="http://schemas.microsoft.com/office/drawing/2014/main" id="{DE325C2E-1C5B-4B69-B4C6-7A0C5AAE913D}"/>
+                <a16:creationId xmlns:a16="http://schemas.microsoft.com/office/drawing/2014/main" id="{727B9F7E-F2F3-47D5-A160-AC8F41B0BB68}"/>
               </a:ext>
             </a:extLst>
           </p:cNvPr>
@@ -8183,7 +8121,7 @@
           <p:cNvPr id="14" name="table-cell-194-1-1">
             <a:extLst xmlns:a="http://schemas.openxmlformats.org/drawingml/2006/main">
               <a:ext uri="{FF2B5EF4-FFF2-40B4-BE49-F238E27FC236}">
-                <a16:creationId xmlns:a16="http://schemas.microsoft.com/office/drawing/2014/main" id="{41077FBC-8868-42B8-A36A-463189A28883}"/>
+                <a16:creationId xmlns:a16="http://schemas.microsoft.com/office/drawing/2014/main" id="{EEF87FFF-91DA-441C-A116-82D5A24FC1A1}"/>
               </a:ext>
             </a:extLst>
           </p:cNvPr>
@@ -8216,7 +8154,7 @@
           <p:cNvPr id="15" name="table-text-194-1-1">
             <a:extLst xmlns:a="http://schemas.openxmlformats.org/drawingml/2006/main">
               <a:ext uri="{FF2B5EF4-FFF2-40B4-BE49-F238E27FC236}">
-                <a16:creationId xmlns:a16="http://schemas.microsoft.com/office/drawing/2014/main" id="{827DA344-C335-4413-A65B-DE67F7046572}"/>
+                <a16:creationId xmlns:a16="http://schemas.microsoft.com/office/drawing/2014/main" id="{B796AF94-E914-4F4E-BDAF-815DD4AC8F3F}"/>
               </a:ext>
             </a:extLst>
           </p:cNvPr>
@@ -8278,7 +8216,7 @@
           <p:cNvPr id="16" name="table-cell-194-1-2">
             <a:extLst xmlns:a="http://schemas.openxmlformats.org/drawingml/2006/main">
               <a:ext uri="{FF2B5EF4-FFF2-40B4-BE49-F238E27FC236}">
-                <a16:creationId xmlns:a16="http://schemas.microsoft.com/office/drawing/2014/main" id="{E98AE31D-CB65-4810-90CA-F8CF5795FF52}"/>
+                <a16:creationId xmlns:a16="http://schemas.microsoft.com/office/drawing/2014/main" id="{F348ACF1-A1E8-4FF6-AA2B-A1BD31B7C382}"/>
               </a:ext>
             </a:extLst>
           </p:cNvPr>
@@ -8311,7 +8249,7 @@
           <p:cNvPr id="17" name="table-text-194-1-2">
             <a:extLst xmlns:a="http://schemas.openxmlformats.org/drawingml/2006/main">
               <a:ext uri="{FF2B5EF4-FFF2-40B4-BE49-F238E27FC236}">
-                <a16:creationId xmlns:a16="http://schemas.microsoft.com/office/drawing/2014/main" id="{E5A941CA-A0AA-4552-9533-2D4CEBB37407}"/>
+                <a16:creationId xmlns:a16="http://schemas.microsoft.com/office/drawing/2014/main" id="{55F4347B-77A7-476D-8AC3-F685290A2368}"/>
               </a:ext>
             </a:extLst>
           </p:cNvPr>
@@ -8373,7 +8311,7 @@
           <p:cNvPr id="18" name="table-cell-194-2-0">
             <a:extLst xmlns:a="http://schemas.openxmlformats.org/drawingml/2006/main">
               <a:ext uri="{FF2B5EF4-FFF2-40B4-BE49-F238E27FC236}">
-                <a16:creationId xmlns:a16="http://schemas.microsoft.com/office/drawing/2014/main" id="{B49C61B2-2F33-48A2-B12F-429DC6AC82BF}"/>
+                <a16:creationId xmlns:a16="http://schemas.microsoft.com/office/drawing/2014/main" id="{8ECF1177-8142-407A-BCF0-115764BF9249}"/>
               </a:ext>
             </a:extLst>
           </p:cNvPr>
@@ -8406,7 +8344,7 @@
           <p:cNvPr id="19" name="table-text-194-2-0">
             <a:extLst xmlns:a="http://schemas.openxmlformats.org/drawingml/2006/main">
               <a:ext uri="{FF2B5EF4-FFF2-40B4-BE49-F238E27FC236}">
-                <a16:creationId xmlns:a16="http://schemas.microsoft.com/office/drawing/2014/main" id="{7A865949-C1AC-4594-9D2B-F4DDAC157121}"/>
+                <a16:creationId xmlns:a16="http://schemas.microsoft.com/office/drawing/2014/main" id="{BD6FEAE8-5D94-46C4-842E-6CA085017964}"/>
               </a:ext>
             </a:extLst>
           </p:cNvPr>
@@ -8468,7 +8406,7 @@
           <p:cNvPr id="20" name="table-cell-194-2-1">
             <a:extLst xmlns:a="http://schemas.openxmlformats.org/drawingml/2006/main">
               <a:ext uri="{FF2B5EF4-FFF2-40B4-BE49-F238E27FC236}">
-                <a16:creationId xmlns:a16="http://schemas.microsoft.com/office/drawing/2014/main" id="{D2FF9B61-B343-4148-9E31-040291230B98}"/>
+                <a16:creationId xmlns:a16="http://schemas.microsoft.com/office/drawing/2014/main" id="{F5E6A93E-2C4E-4504-943B-BA1508CDA676}"/>
               </a:ext>
             </a:extLst>
           </p:cNvPr>
@@ -8501,7 +8439,7 @@
           <p:cNvPr id="21" name="table-text-194-2-1">
             <a:extLst xmlns:a="http://schemas.openxmlformats.org/drawingml/2006/main">
               <a:ext uri="{FF2B5EF4-FFF2-40B4-BE49-F238E27FC236}">
-                <a16:creationId xmlns:a16="http://schemas.microsoft.com/office/drawing/2014/main" id="{929D91C9-837A-49B0-855D-BF42AB12F72B}"/>
+                <a16:creationId xmlns:a16="http://schemas.microsoft.com/office/drawing/2014/main" id="{0EE5FFD0-7840-460E-BFA9-316BA1986421}"/>
               </a:ext>
             </a:extLst>
           </p:cNvPr>
@@ -8563,7 +8501,7 @@
           <p:cNvPr id="22" name="table-cell-194-2-2">
             <a:extLst xmlns:a="http://schemas.openxmlformats.org/drawingml/2006/main">
               <a:ext uri="{FF2B5EF4-FFF2-40B4-BE49-F238E27FC236}">
-                <a16:creationId xmlns:a16="http://schemas.microsoft.com/office/drawing/2014/main" id="{02AFB72C-390D-4002-B60D-AC15F6AB84EB}"/>
+                <a16:creationId xmlns:a16="http://schemas.microsoft.com/office/drawing/2014/main" id="{82A0434E-078B-4DA4-B25C-79DFA2D65867}"/>
               </a:ext>
             </a:extLst>
           </p:cNvPr>
@@ -8596,7 +8534,7 @@
           <p:cNvPr id="23" name="table-text-194-2-2">
             <a:extLst xmlns:a="http://schemas.openxmlformats.org/drawingml/2006/main">
               <a:ext uri="{FF2B5EF4-FFF2-40B4-BE49-F238E27FC236}">
-                <a16:creationId xmlns:a16="http://schemas.microsoft.com/office/drawing/2014/main" id="{EC2558FB-8DBF-421C-906D-70CD9B65B2BD}"/>
+                <a16:creationId xmlns:a16="http://schemas.microsoft.com/office/drawing/2014/main" id="{1F8C95DA-F130-4C42-B40B-5C03BECFC09D}"/>
               </a:ext>
             </a:extLst>
           </p:cNvPr>
@@ -8658,7 +8596,7 @@
           <p:cNvPr id="24" name="table-cell-194-3-0">
             <a:extLst xmlns:a="http://schemas.openxmlformats.org/drawingml/2006/main">
               <a:ext uri="{FF2B5EF4-FFF2-40B4-BE49-F238E27FC236}">
-                <a16:creationId xmlns:a16="http://schemas.microsoft.com/office/drawing/2014/main" id="{95E82C93-E3AA-48A4-8091-B7737A1F8C73}"/>
+                <a16:creationId xmlns:a16="http://schemas.microsoft.com/office/drawing/2014/main" id="{18923242-DEA0-406E-8B3E-741ABF269586}"/>
               </a:ext>
             </a:extLst>
           </p:cNvPr>
@@ -8691,7 +8629,7 @@
           <p:cNvPr id="25" name="table-text-194-3-0">
             <a:extLst xmlns:a="http://schemas.openxmlformats.org/drawingml/2006/main">
               <a:ext uri="{FF2B5EF4-FFF2-40B4-BE49-F238E27FC236}">
-                <a16:creationId xmlns:a16="http://schemas.microsoft.com/office/drawing/2014/main" id="{F03FD298-176C-4C87-8AA3-5903B7047651}"/>
+                <a16:creationId xmlns:a16="http://schemas.microsoft.com/office/drawing/2014/main" id="{831790F1-1204-42C4-8A34-8F05F80DE6B9}"/>
               </a:ext>
             </a:extLst>
           </p:cNvPr>
@@ -8753,7 +8691,7 @@
           <p:cNvPr id="26" name="table-cell-194-3-1">
             <a:extLst xmlns:a="http://schemas.openxmlformats.org/drawingml/2006/main">
               <a:ext uri="{FF2B5EF4-FFF2-40B4-BE49-F238E27FC236}">
-                <a16:creationId xmlns:a16="http://schemas.microsoft.com/office/drawing/2014/main" id="{3879C48E-5C1C-435A-90DA-5A18F6607F81}"/>
+                <a16:creationId xmlns:a16="http://schemas.microsoft.com/office/drawing/2014/main" id="{76E845BE-7B5B-4D83-9688-38ADF0FCA471}"/>
               </a:ext>
             </a:extLst>
           </p:cNvPr>
@@ -8786,7 +8724,7 @@
           <p:cNvPr id="27" name="table-text-194-3-1">
             <a:extLst xmlns:a="http://schemas.openxmlformats.org/drawingml/2006/main">
               <a:ext uri="{FF2B5EF4-FFF2-40B4-BE49-F238E27FC236}">
-                <a16:creationId xmlns:a16="http://schemas.microsoft.com/office/drawing/2014/main" id="{D3CEDA8D-8E8D-4D58-8F15-B6D0D5D63E64}"/>
+                <a16:creationId xmlns:a16="http://schemas.microsoft.com/office/drawing/2014/main" id="{E4D29266-D821-4C5F-BECA-2BCD13ACEBCD}"/>
               </a:ext>
             </a:extLst>
           </p:cNvPr>
@@ -8848,7 +8786,7 @@
           <p:cNvPr id="28" name="table-cell-194-3-2">
             <a:extLst xmlns:a="http://schemas.openxmlformats.org/drawingml/2006/main">
               <a:ext uri="{FF2B5EF4-FFF2-40B4-BE49-F238E27FC236}">
-                <a16:creationId xmlns:a16="http://schemas.microsoft.com/office/drawing/2014/main" id="{DD3741E5-F43D-46A6-AE87-C5A6FDE5499C}"/>
+                <a16:creationId xmlns:a16="http://schemas.microsoft.com/office/drawing/2014/main" id="{F2D51CE5-753F-4A1F-8E3E-BFB4437C1896}"/>
               </a:ext>
             </a:extLst>
           </p:cNvPr>
@@ -8881,7 +8819,7 @@
           <p:cNvPr id="29" name="table-text-194-3-2">
             <a:extLst xmlns:a="http://schemas.openxmlformats.org/drawingml/2006/main">
               <a:ext uri="{FF2B5EF4-FFF2-40B4-BE49-F238E27FC236}">
-                <a16:creationId xmlns:a16="http://schemas.microsoft.com/office/drawing/2014/main" id="{CC4909C3-FBC8-4DCE-828B-3B100545681A}"/>
+                <a16:creationId xmlns:a16="http://schemas.microsoft.com/office/drawing/2014/main" id="{4748E944-3A17-4231-904F-0836F9D7A3D3}"/>
               </a:ext>
             </a:extLst>
           </p:cNvPr>
@@ -8943,7 +8881,7 @@
           <p:cNvPr id="30" name="table-cell-194-4-0">
             <a:extLst xmlns:a="http://schemas.openxmlformats.org/drawingml/2006/main">
               <a:ext uri="{FF2B5EF4-FFF2-40B4-BE49-F238E27FC236}">
-                <a16:creationId xmlns:a16="http://schemas.microsoft.com/office/drawing/2014/main" id="{4BD68259-297E-4DE2-9B47-1D442BFA86B3}"/>
+                <a16:creationId xmlns:a16="http://schemas.microsoft.com/office/drawing/2014/main" id="{C5733415-8038-41EB-8D50-F1D18A02DD25}"/>
               </a:ext>
             </a:extLst>
           </p:cNvPr>
@@ -8976,7 +8914,7 @@
           <p:cNvPr id="31" name="table-text-194-4-0">
             <a:extLst xmlns:a="http://schemas.openxmlformats.org/drawingml/2006/main">
               <a:ext uri="{FF2B5EF4-FFF2-40B4-BE49-F238E27FC236}">
-                <a16:creationId xmlns:a16="http://schemas.microsoft.com/office/drawing/2014/main" id="{31D9D66A-CB3A-469B-BA0A-D988ECF3AD76}"/>
+                <a16:creationId xmlns:a16="http://schemas.microsoft.com/office/drawing/2014/main" id="{CE11A12E-B4BC-4974-B3F3-1FF15DF43809}"/>
               </a:ext>
             </a:extLst>
           </p:cNvPr>
@@ -9038,7 +8976,7 @@
           <p:cNvPr id="32" name="table-cell-194-4-1">
             <a:extLst xmlns:a="http://schemas.openxmlformats.org/drawingml/2006/main">
               <a:ext uri="{FF2B5EF4-FFF2-40B4-BE49-F238E27FC236}">
-                <a16:creationId xmlns:a16="http://schemas.microsoft.com/office/drawing/2014/main" id="{FA306F34-B279-4A55-AEAE-01C8915A0648}"/>
+                <a16:creationId xmlns:a16="http://schemas.microsoft.com/office/drawing/2014/main" id="{4F9850A9-833C-4D74-9EA5-A0931F931756}"/>
               </a:ext>
             </a:extLst>
           </p:cNvPr>
@@ -9071,7 +9009,7 @@
           <p:cNvPr id="33" name="table-text-194-4-1">
             <a:extLst xmlns:a="http://schemas.openxmlformats.org/drawingml/2006/main">
               <a:ext uri="{FF2B5EF4-FFF2-40B4-BE49-F238E27FC236}">
-                <a16:creationId xmlns:a16="http://schemas.microsoft.com/office/drawing/2014/main" id="{11AD1138-5675-4CF6-A56C-D519C6FD1A41}"/>
+                <a16:creationId xmlns:a16="http://schemas.microsoft.com/office/drawing/2014/main" id="{BE45D178-519F-4ABE-B1F4-35047B4C6E65}"/>
               </a:ext>
             </a:extLst>
           </p:cNvPr>
@@ -9133,7 +9071,7 @@
           <p:cNvPr id="34" name="table-cell-194-4-2">
             <a:extLst xmlns:a="http://schemas.openxmlformats.org/drawingml/2006/main">
               <a:ext uri="{FF2B5EF4-FFF2-40B4-BE49-F238E27FC236}">
-                <a16:creationId xmlns:a16="http://schemas.microsoft.com/office/drawing/2014/main" id="{7174A7A2-BE66-416D-A891-26AE4CD2AC54}"/>
+                <a16:creationId xmlns:a16="http://schemas.microsoft.com/office/drawing/2014/main" id="{63D144BB-9CBE-45C4-80BA-7BAA061088F5}"/>
               </a:ext>
             </a:extLst>
           </p:cNvPr>
@@ -9166,7 +9104,7 @@
           <p:cNvPr id="35" name="table-text-194-4-2">
             <a:extLst xmlns:a="http://schemas.openxmlformats.org/drawingml/2006/main">
               <a:ext uri="{FF2B5EF4-FFF2-40B4-BE49-F238E27FC236}">
-                <a16:creationId xmlns:a16="http://schemas.microsoft.com/office/drawing/2014/main" id="{BB39E097-F72A-40D9-A58E-5E66F0D6A620}"/>
+                <a16:creationId xmlns:a16="http://schemas.microsoft.com/office/drawing/2014/main" id="{E8358849-C5BE-423D-8AAB-C9FE78F25CB3}"/>
               </a:ext>
             </a:extLst>
           </p:cNvPr>
@@ -9232,7 +9170,7 @@
           <p:nvPr/>
         </p:nvPicPr>
         <p:blipFill>
-          <a:blip xmlns:r="http://schemas.openxmlformats.org/officeDocument/2006/relationships" xmlns:a="http://schemas.openxmlformats.org/drawingml/2006/main" r:embed="R93f2f55e2ae24522"/>
+          <a:blip xmlns:r="http://schemas.openxmlformats.org/officeDocument/2006/relationships" xmlns:a="http://schemas.openxmlformats.org/drawingml/2006/main" r:embed="R8ebc3b427c7442ff"/>
           <a:stretch xmlns:a="http://schemas.openxmlformats.org/drawingml/2006/main"/>
         </p:blipFill>
         <p:spPr>
@@ -9252,7 +9190,7 @@
           <p:cNvPr id="37" name="image-caption-426">
             <a:extLst xmlns:a="http://schemas.openxmlformats.org/drawingml/2006/main">
               <a:ext uri="{FF2B5EF4-FFF2-40B4-BE49-F238E27FC236}">
-                <a16:creationId xmlns:a16="http://schemas.microsoft.com/office/drawing/2014/main" id="{86985AC7-06D3-4917-B99D-5BAF6A1D2AC3}"/>
+                <a16:creationId xmlns:a16="http://schemas.microsoft.com/office/drawing/2014/main" id="{4143FB9C-6559-45CA-BB1D-0EB36B3DF2DA}"/>
               </a:ext>
             </a:extLst>
           </p:cNvPr>
@@ -9312,7 +9250,7 @@
     </p:spTree>
     <p:extLst>
       <p:ext uri="{BB962C8B-B14F-4D97-AF65-F5344CB8AC3E}">
-        <p14:creationId xmlns:p14="http://schemas.microsoft.com/office/powerpoint/2010/main" val="2056349240"/>
+        <p14:creationId xmlns:p14="http://schemas.microsoft.com/office/powerpoint/2010/main" val="516232764"/>
       </p:ext>
     </p:extLst>
   </p:cSld>
@@ -9343,7 +9281,7 @@
           <p:cNvPr id="9" name="running-label">
             <a:extLst xmlns:a="http://schemas.openxmlformats.org/drawingml/2006/main">
               <a:ext uri="{FF2B5EF4-FFF2-40B4-BE49-F238E27FC236}">
-                <a16:creationId xmlns:a16="http://schemas.microsoft.com/office/drawing/2014/main" id="{CD971789-5269-497E-80A7-8EBE31F8F1F1}"/>
+                <a16:creationId xmlns:a16="http://schemas.microsoft.com/office/drawing/2014/main" id="{BA90B740-9729-4DFF-80D1-B14C9133B535}"/>
               </a:ext>
             </a:extLst>
           </p:cNvPr>
@@ -9405,7 +9343,7 @@
           <p:cNvPr id="2" name="page-number">
             <a:extLst xmlns:a="http://schemas.openxmlformats.org/drawingml/2006/main">
               <a:ext uri="{FF2B5EF4-FFF2-40B4-BE49-F238E27FC236}">
-                <a16:creationId xmlns:a16="http://schemas.microsoft.com/office/drawing/2014/main" id="{E2EB24E4-DAB2-4B9B-BE7F-C7DEAD02F91C}"/>
+                <a16:creationId xmlns:a16="http://schemas.microsoft.com/office/drawing/2014/main" id="{B5EAAE15-1D02-4D25-A5CE-BCADBBE6C0F0}"/>
               </a:ext>
             </a:extLst>
           </p:cNvPr>
@@ -9467,7 +9405,7 @@
           <p:cNvPr id="3" name="header-rule">
             <a:extLst xmlns:a="http://schemas.openxmlformats.org/drawingml/2006/main">
               <a:ext uri="{FF2B5EF4-FFF2-40B4-BE49-F238E27FC236}">
-                <a16:creationId xmlns:a16="http://schemas.microsoft.com/office/drawing/2014/main" id="{24132F12-C032-4DE3-93F3-E243F4E8E1C0}"/>
+                <a16:creationId xmlns:a16="http://schemas.microsoft.com/office/drawing/2014/main" id="{ED32C754-81CA-4900-BD62-B06853AC9528}"/>
               </a:ext>
             </a:extLst>
           </p:cNvPr>
@@ -9498,7 +9436,7 @@
           <p:cNvPr id="4" name="slide-title">
             <a:extLst xmlns:a="http://schemas.openxmlformats.org/drawingml/2006/main">
               <a:ext uri="{FF2B5EF4-FFF2-40B4-BE49-F238E27FC236}">
-                <a16:creationId xmlns:a16="http://schemas.microsoft.com/office/drawing/2014/main" id="{DB83454B-F54E-48F3-8190-3564C44192C2}"/>
+                <a16:creationId xmlns:a16="http://schemas.microsoft.com/office/drawing/2014/main" id="{F621D32E-B5DE-47EE-A92F-C3401D9BD8C9}"/>
               </a:ext>
             </a:extLst>
           </p:cNvPr>
@@ -9564,7 +9502,7 @@
           <p:nvPr/>
         </p:nvPicPr>
         <p:blipFill>
-          <a:blip xmlns:r="http://schemas.openxmlformats.org/officeDocument/2006/relationships" xmlns:a="http://schemas.openxmlformats.org/drawingml/2006/main" r:embed="R6029080ad77549b3"/>
+          <a:blip xmlns:r="http://schemas.openxmlformats.org/officeDocument/2006/relationships" xmlns:a="http://schemas.openxmlformats.org/drawingml/2006/main" r:embed="R24c32311650f40be"/>
           <a:stretch xmlns:a="http://schemas.openxmlformats.org/drawingml/2006/main"/>
         </p:blipFill>
         <p:spPr>
@@ -9584,7 +9522,7 @@
           <p:cNvPr id="6" name="image-caption-140">
             <a:extLst xmlns:a="http://schemas.openxmlformats.org/drawingml/2006/main">
               <a:ext uri="{FF2B5EF4-FFF2-40B4-BE49-F238E27FC236}">
-                <a16:creationId xmlns:a16="http://schemas.microsoft.com/office/drawing/2014/main" id="{2A9D5CBD-9A32-4616-8B23-5DCD8260F556}"/>
+                <a16:creationId xmlns:a16="http://schemas.microsoft.com/office/drawing/2014/main" id="{5BACDCB8-D761-4E52-8382-4FADA298E7E8}"/>
               </a:ext>
             </a:extLst>
           </p:cNvPr>
@@ -9650,7 +9588,7 @@
           <p:nvPr/>
         </p:nvPicPr>
         <p:blipFill>
-          <a:blip xmlns:r="http://schemas.openxmlformats.org/officeDocument/2006/relationships" xmlns:a="http://schemas.openxmlformats.org/drawingml/2006/main" r:embed="R0e784c99b28848ed"/>
+          <a:blip xmlns:r="http://schemas.openxmlformats.org/officeDocument/2006/relationships" xmlns:a="http://schemas.openxmlformats.org/drawingml/2006/main" r:embed="Rb93aadf0d62e4a5d"/>
           <a:stretch xmlns:a="http://schemas.openxmlformats.org/drawingml/2006/main"/>
         </p:blipFill>
         <p:spPr>
@@ -9670,7 +9608,7 @@
           <p:cNvPr id="8" name="image-caption-524">
             <a:extLst xmlns:a="http://schemas.openxmlformats.org/drawingml/2006/main">
               <a:ext uri="{FF2B5EF4-FFF2-40B4-BE49-F238E27FC236}">
-                <a16:creationId xmlns:a16="http://schemas.microsoft.com/office/drawing/2014/main" id="{7827E559-9676-4454-8235-EDFD7B346AD0}"/>
+                <a16:creationId xmlns:a16="http://schemas.microsoft.com/office/drawing/2014/main" id="{3A2817FD-0674-4A53-84AE-04DBEEBCCA90}"/>
               </a:ext>
             </a:extLst>
           </p:cNvPr>
@@ -9730,7 +9668,7 @@
     </p:spTree>
     <p:extLst>
       <p:ext uri="{BB962C8B-B14F-4D97-AF65-F5344CB8AC3E}">
-        <p14:creationId xmlns:p14="http://schemas.microsoft.com/office/powerpoint/2010/main" val="1990111449"/>
+        <p14:creationId xmlns:p14="http://schemas.microsoft.com/office/powerpoint/2010/main" val="1365758294"/>
       </p:ext>
     </p:extLst>
   </p:cSld>
@@ -9761,7 +9699,7 @@
           <p:cNvPr id="45" name="running-label">
             <a:extLst xmlns:a="http://schemas.openxmlformats.org/drawingml/2006/main">
               <a:ext uri="{FF2B5EF4-FFF2-40B4-BE49-F238E27FC236}">
-                <a16:creationId xmlns:a16="http://schemas.microsoft.com/office/drawing/2014/main" id="{0CB5A9E3-0C9A-4A14-959B-045C4C03EC11}"/>
+                <a16:creationId xmlns:a16="http://schemas.microsoft.com/office/drawing/2014/main" id="{275D85BD-7D4F-4725-BC1A-3DBCAA21CE76}"/>
               </a:ext>
             </a:extLst>
           </p:cNvPr>
@@ -9823,7 +9761,7 @@
           <p:cNvPr id="2" name="page-number">
             <a:extLst xmlns:a="http://schemas.openxmlformats.org/drawingml/2006/main">
               <a:ext uri="{FF2B5EF4-FFF2-40B4-BE49-F238E27FC236}">
-                <a16:creationId xmlns:a16="http://schemas.microsoft.com/office/drawing/2014/main" id="{8125510F-6837-4A31-8313-A9E4C60124DD}"/>
+                <a16:creationId xmlns:a16="http://schemas.microsoft.com/office/drawing/2014/main" id="{9B1A6EB6-E7B3-4B05-8C49-FACABCFEAB91}"/>
               </a:ext>
             </a:extLst>
           </p:cNvPr>
@@ -9885,7 +9823,7 @@
           <p:cNvPr id="3" name="header-rule">
             <a:extLst xmlns:a="http://schemas.openxmlformats.org/drawingml/2006/main">
               <a:ext uri="{FF2B5EF4-FFF2-40B4-BE49-F238E27FC236}">
-                <a16:creationId xmlns:a16="http://schemas.microsoft.com/office/drawing/2014/main" id="{377C8DDA-C1BC-4F74-AFA5-9FD54B9C64BB}"/>
+                <a16:creationId xmlns:a16="http://schemas.microsoft.com/office/drawing/2014/main" id="{6268DC42-3F51-4AFC-948C-64F2AC5072F1}"/>
               </a:ext>
             </a:extLst>
           </p:cNvPr>
@@ -9916,7 +9854,7 @@
           <p:cNvPr id="4" name="slide-title">
             <a:extLst xmlns:a="http://schemas.openxmlformats.org/drawingml/2006/main">
               <a:ext uri="{FF2B5EF4-FFF2-40B4-BE49-F238E27FC236}">
-                <a16:creationId xmlns:a16="http://schemas.microsoft.com/office/drawing/2014/main" id="{55D38AF8-ACDD-4909-A96B-E629B8700AAB}"/>
+                <a16:creationId xmlns:a16="http://schemas.microsoft.com/office/drawing/2014/main" id="{537659DC-05F9-4FE5-B255-C7C704832556}"/>
               </a:ext>
             </a:extLst>
           </p:cNvPr>
@@ -9982,7 +9920,7 @@
           <p:nvPr/>
         </p:nvPicPr>
         <p:blipFill>
-          <a:blip xmlns:r="http://schemas.openxmlformats.org/officeDocument/2006/relationships" xmlns:a="http://schemas.openxmlformats.org/drawingml/2006/main" r:embed="Red36327a14ba4a0a"/>
+          <a:blip xmlns:r="http://schemas.openxmlformats.org/officeDocument/2006/relationships" xmlns:a="http://schemas.openxmlformats.org/drawingml/2006/main" r:embed="Rb2a778a5232143c6"/>
           <a:stretch xmlns:a="http://schemas.openxmlformats.org/drawingml/2006/main"/>
         </p:blipFill>
         <p:spPr>
@@ -10002,7 +9940,7 @@
           <p:cNvPr id="6" name="image-caption-140">
             <a:extLst xmlns:a="http://schemas.openxmlformats.org/drawingml/2006/main">
               <a:ext uri="{FF2B5EF4-FFF2-40B4-BE49-F238E27FC236}">
-                <a16:creationId xmlns:a16="http://schemas.microsoft.com/office/drawing/2014/main" id="{3C6BBA28-26D5-42CC-AF11-715E70011099}"/>
+                <a16:creationId xmlns:a16="http://schemas.microsoft.com/office/drawing/2014/main" id="{4824738F-F13F-439A-B6EE-C3256C1828C1}"/>
               </a:ext>
             </a:extLst>
           </p:cNvPr>
@@ -10064,7 +10002,7 @@
           <p:cNvPr id="7" name="subheading-524">
             <a:extLst xmlns:a="http://schemas.openxmlformats.org/drawingml/2006/main">
               <a:ext uri="{FF2B5EF4-FFF2-40B4-BE49-F238E27FC236}">
-                <a16:creationId xmlns:a16="http://schemas.microsoft.com/office/drawing/2014/main" id="{F2406F23-89CB-446B-B778-AF9E960CA07C}"/>
+                <a16:creationId xmlns:a16="http://schemas.microsoft.com/office/drawing/2014/main" id="{96B975A0-5E9D-407E-8A4C-1C36A9A520F5}"/>
               </a:ext>
             </a:extLst>
           </p:cNvPr>
@@ -10126,7 +10064,7 @@
           <p:cNvPr id="8" name="table-cell-578-0-0">
             <a:extLst xmlns:a="http://schemas.openxmlformats.org/drawingml/2006/main">
               <a:ext uri="{FF2B5EF4-FFF2-40B4-BE49-F238E27FC236}">
-                <a16:creationId xmlns:a16="http://schemas.microsoft.com/office/drawing/2014/main" id="{8E4337B0-4F5D-4185-B485-2DB6185F9167}"/>
+                <a16:creationId xmlns:a16="http://schemas.microsoft.com/office/drawing/2014/main" id="{80F19F43-122B-46D9-ABE8-4F349B674440}"/>
               </a:ext>
             </a:extLst>
           </p:cNvPr>
@@ -10159,7 +10097,7 @@
           <p:cNvPr id="9" name="table-text-578-0-0">
             <a:extLst xmlns:a="http://schemas.openxmlformats.org/drawingml/2006/main">
               <a:ext uri="{FF2B5EF4-FFF2-40B4-BE49-F238E27FC236}">
-                <a16:creationId xmlns:a16="http://schemas.microsoft.com/office/drawing/2014/main" id="{8990D072-33D5-4721-9080-DB82E7F40C03}"/>
+                <a16:creationId xmlns:a16="http://schemas.microsoft.com/office/drawing/2014/main" id="{169A2889-FC50-4182-84A6-0AFBD8BA98AF}"/>
               </a:ext>
             </a:extLst>
           </p:cNvPr>
@@ -10221,7 +10159,7 @@
           <p:cNvPr id="10" name="table-cell-578-0-1">
             <a:extLst xmlns:a="http://schemas.openxmlformats.org/drawingml/2006/main">
               <a:ext uri="{FF2B5EF4-FFF2-40B4-BE49-F238E27FC236}">
-                <a16:creationId xmlns:a16="http://schemas.microsoft.com/office/drawing/2014/main" id="{31332730-639A-42DD-8A2D-29CF530D4916}"/>
+                <a16:creationId xmlns:a16="http://schemas.microsoft.com/office/drawing/2014/main" id="{7056463B-B12C-40D7-8A82-127C1A88F5B9}"/>
               </a:ext>
             </a:extLst>
           </p:cNvPr>
@@ -10254,7 +10192,7 @@
           <p:cNvPr id="11" name="table-text-578-0-1">
             <a:extLst xmlns:a="http://schemas.openxmlformats.org/drawingml/2006/main">
               <a:ext uri="{FF2B5EF4-FFF2-40B4-BE49-F238E27FC236}">
-                <a16:creationId xmlns:a16="http://schemas.microsoft.com/office/drawing/2014/main" id="{6AB7C106-F8BA-4388-BFDB-5EE5E8354AB1}"/>
+                <a16:creationId xmlns:a16="http://schemas.microsoft.com/office/drawing/2014/main" id="{D83125F1-8837-44DA-A1EE-46FBA615D59F}"/>
               </a:ext>
             </a:extLst>
           </p:cNvPr>
@@ -10316,7 +10254,7 @@
           <p:cNvPr id="12" name="table-cell-578-0-2">
             <a:extLst xmlns:a="http://schemas.openxmlformats.org/drawingml/2006/main">
               <a:ext uri="{FF2B5EF4-FFF2-40B4-BE49-F238E27FC236}">
-                <a16:creationId xmlns:a16="http://schemas.microsoft.com/office/drawing/2014/main" id="{7CF89653-00DC-4FF3-9D4D-67550CB24CCE}"/>
+                <a16:creationId xmlns:a16="http://schemas.microsoft.com/office/drawing/2014/main" id="{85183A8A-4B5B-4DEF-9BEC-7C4B9CBE87DC}"/>
               </a:ext>
             </a:extLst>
           </p:cNvPr>
@@ -10349,7 +10287,7 @@
           <p:cNvPr id="13" name="table-text-578-0-2">
             <a:extLst xmlns:a="http://schemas.openxmlformats.org/drawingml/2006/main">
               <a:ext uri="{FF2B5EF4-FFF2-40B4-BE49-F238E27FC236}">
-                <a16:creationId xmlns:a16="http://schemas.microsoft.com/office/drawing/2014/main" id="{CFD36D9F-EA96-461C-9253-321A34E2F539}"/>
+                <a16:creationId xmlns:a16="http://schemas.microsoft.com/office/drawing/2014/main" id="{9CD99561-177C-4D55-9699-0C80759ED6B1}"/>
               </a:ext>
             </a:extLst>
           </p:cNvPr>
@@ -10411,7 +10349,7 @@
           <p:cNvPr id="14" name="table-cell-578-1-0">
             <a:extLst xmlns:a="http://schemas.openxmlformats.org/drawingml/2006/main">
               <a:ext uri="{FF2B5EF4-FFF2-40B4-BE49-F238E27FC236}">
-                <a16:creationId xmlns:a16="http://schemas.microsoft.com/office/drawing/2014/main" id="{43C64762-D607-438E-A8DD-8E4198859178}"/>
+                <a16:creationId xmlns:a16="http://schemas.microsoft.com/office/drawing/2014/main" id="{7FFCCF85-43EE-4B8E-968C-68DCC1AB6C4A}"/>
               </a:ext>
             </a:extLst>
           </p:cNvPr>
@@ -10444,7 +10382,7 @@
           <p:cNvPr id="15" name="table-text-578-1-0">
             <a:extLst xmlns:a="http://schemas.openxmlformats.org/drawingml/2006/main">
               <a:ext uri="{FF2B5EF4-FFF2-40B4-BE49-F238E27FC236}">
-                <a16:creationId xmlns:a16="http://schemas.microsoft.com/office/drawing/2014/main" id="{FE7A765F-6BF2-4E7F-81DC-122126D3D8BC}"/>
+                <a16:creationId xmlns:a16="http://schemas.microsoft.com/office/drawing/2014/main" id="{084CD465-3B19-4536-9252-051E4DF95C33}"/>
               </a:ext>
             </a:extLst>
           </p:cNvPr>
@@ -10506,7 +10444,7 @@
           <p:cNvPr id="16" name="table-cell-578-1-1">
             <a:extLst xmlns:a="http://schemas.openxmlformats.org/drawingml/2006/main">
               <a:ext uri="{FF2B5EF4-FFF2-40B4-BE49-F238E27FC236}">
-                <a16:creationId xmlns:a16="http://schemas.microsoft.com/office/drawing/2014/main" id="{046DA95E-E02A-46E6-91F1-95C31BABB3A1}"/>
+                <a16:creationId xmlns:a16="http://schemas.microsoft.com/office/drawing/2014/main" id="{76999E7B-680F-4069-AFC7-8A4ED82270DE}"/>
               </a:ext>
             </a:extLst>
           </p:cNvPr>
@@ -10539,7 +10477,7 @@
           <p:cNvPr id="17" name="table-text-578-1-1">
             <a:extLst xmlns:a="http://schemas.openxmlformats.org/drawingml/2006/main">
               <a:ext uri="{FF2B5EF4-FFF2-40B4-BE49-F238E27FC236}">
-                <a16:creationId xmlns:a16="http://schemas.microsoft.com/office/drawing/2014/main" id="{547FFBF0-838A-4A69-A7D9-12C5411EA22E}"/>
+                <a16:creationId xmlns:a16="http://schemas.microsoft.com/office/drawing/2014/main" id="{E78EDB2C-4A32-489E-A2C8-C25F05305143}"/>
               </a:ext>
             </a:extLst>
           </p:cNvPr>
@@ -10601,7 +10539,7 @@
           <p:cNvPr id="18" name="table-cell-578-1-2">
             <a:extLst xmlns:a="http://schemas.openxmlformats.org/drawingml/2006/main">
               <a:ext uri="{FF2B5EF4-FFF2-40B4-BE49-F238E27FC236}">
-                <a16:creationId xmlns:a16="http://schemas.microsoft.com/office/drawing/2014/main" id="{975A6128-C2EA-4ECA-880A-D025243C3EE4}"/>
+                <a16:creationId xmlns:a16="http://schemas.microsoft.com/office/drawing/2014/main" id="{33B8ED01-91E2-4723-A254-76E46DACFD1D}"/>
               </a:ext>
             </a:extLst>
           </p:cNvPr>
@@ -10634,7 +10572,7 @@
           <p:cNvPr id="19" name="table-text-578-1-2">
             <a:extLst xmlns:a="http://schemas.openxmlformats.org/drawingml/2006/main">
               <a:ext uri="{FF2B5EF4-FFF2-40B4-BE49-F238E27FC236}">
-                <a16:creationId xmlns:a16="http://schemas.microsoft.com/office/drawing/2014/main" id="{DEF9F1A6-FF06-4F4C-9A33-2EFFE52C0776}"/>
+                <a16:creationId xmlns:a16="http://schemas.microsoft.com/office/drawing/2014/main" id="{6A6482EC-EF13-4881-9DB0-8A6501A508B7}"/>
               </a:ext>
             </a:extLst>
           </p:cNvPr>
@@ -10696,7 +10634,7 @@
           <p:cNvPr id="20" name="table-cell-578-2-0">
             <a:extLst xmlns:a="http://schemas.openxmlformats.org/drawingml/2006/main">
               <a:ext uri="{FF2B5EF4-FFF2-40B4-BE49-F238E27FC236}">
-                <a16:creationId xmlns:a16="http://schemas.microsoft.com/office/drawing/2014/main" id="{FE30FF46-BF84-4677-8A8C-475A11096B76}"/>
+                <a16:creationId xmlns:a16="http://schemas.microsoft.com/office/drawing/2014/main" id="{5FE8919A-53B1-45C1-9F54-D819AD6F0D35}"/>
               </a:ext>
             </a:extLst>
           </p:cNvPr>
@@ -10729,7 +10667,7 @@
           <p:cNvPr id="21" name="table-text-578-2-0">
             <a:extLst xmlns:a="http://schemas.openxmlformats.org/drawingml/2006/main">
               <a:ext uri="{FF2B5EF4-FFF2-40B4-BE49-F238E27FC236}">
-                <a16:creationId xmlns:a16="http://schemas.microsoft.com/office/drawing/2014/main" id="{D839FAC9-DEFC-4397-903D-5038B9C95320}"/>
+                <a16:creationId xmlns:a16="http://schemas.microsoft.com/office/drawing/2014/main" id="{B951895E-EB9E-40CC-86B3-F86C8B023D56}"/>
               </a:ext>
             </a:extLst>
           </p:cNvPr>
@@ -10791,7 +10729,7 @@
           <p:cNvPr id="22" name="table-cell-578-2-1">
             <a:extLst xmlns:a="http://schemas.openxmlformats.org/drawingml/2006/main">
               <a:ext uri="{FF2B5EF4-FFF2-40B4-BE49-F238E27FC236}">
-                <a16:creationId xmlns:a16="http://schemas.microsoft.com/office/drawing/2014/main" id="{9380877C-93F7-40CC-AA07-52B8C58F8CA3}"/>
+                <a16:creationId xmlns:a16="http://schemas.microsoft.com/office/drawing/2014/main" id="{3C3C5D4B-8D90-48A3-BDEB-E578AA711BAA}"/>
               </a:ext>
             </a:extLst>
           </p:cNvPr>
@@ -10824,7 +10762,7 @@
           <p:cNvPr id="23" name="table-text-578-2-1">
             <a:extLst xmlns:a="http://schemas.openxmlformats.org/drawingml/2006/main">
               <a:ext uri="{FF2B5EF4-FFF2-40B4-BE49-F238E27FC236}">
-                <a16:creationId xmlns:a16="http://schemas.microsoft.com/office/drawing/2014/main" id="{16E13F82-C7F7-442A-AFDA-8BC4E3787AC5}"/>
+                <a16:creationId xmlns:a16="http://schemas.microsoft.com/office/drawing/2014/main" id="{6777F150-1554-443F-A99C-88849139607F}"/>
               </a:ext>
             </a:extLst>
           </p:cNvPr>
@@ -10886,7 +10824,7 @@
           <p:cNvPr id="24" name="table-cell-578-2-2">
             <a:extLst xmlns:a="http://schemas.openxmlformats.org/drawingml/2006/main">
               <a:ext uri="{FF2B5EF4-FFF2-40B4-BE49-F238E27FC236}">
-                <a16:creationId xmlns:a16="http://schemas.microsoft.com/office/drawing/2014/main" id="{9CDF64A6-326A-4E73-8482-057C65567073}"/>
+                <a16:creationId xmlns:a16="http://schemas.microsoft.com/office/drawing/2014/main" id="{DDC165AE-7913-4705-93F1-729EF0ECC04E}"/>
               </a:ext>
             </a:extLst>
           </p:cNvPr>
@@ -10919,7 +10857,7 @@
           <p:cNvPr id="25" name="table-text-578-2-2">
             <a:extLst xmlns:a="http://schemas.openxmlformats.org/drawingml/2006/main">
               <a:ext uri="{FF2B5EF4-FFF2-40B4-BE49-F238E27FC236}">
-                <a16:creationId xmlns:a16="http://schemas.microsoft.com/office/drawing/2014/main" id="{1329B1A4-DA41-4EBF-8D07-88BE3BB9E411}"/>
+                <a16:creationId xmlns:a16="http://schemas.microsoft.com/office/drawing/2014/main" id="{F463ECB5-1F40-4AD0-8127-059B38C68E7C}"/>
               </a:ext>
             </a:extLst>
           </p:cNvPr>
@@ -10981,7 +10919,7 @@
           <p:cNvPr id="26" name="table-cell-578-3-0">
             <a:extLst xmlns:a="http://schemas.openxmlformats.org/drawingml/2006/main">
               <a:ext uri="{FF2B5EF4-FFF2-40B4-BE49-F238E27FC236}">
-                <a16:creationId xmlns:a16="http://schemas.microsoft.com/office/drawing/2014/main" id="{0D73CE7B-6ED4-4E3E-9789-00F2CBBE323F}"/>
+                <a16:creationId xmlns:a16="http://schemas.microsoft.com/office/drawing/2014/main" id="{87965AC0-9B49-4B01-9069-657B20E13B05}"/>
               </a:ext>
             </a:extLst>
           </p:cNvPr>
@@ -11014,7 +10952,7 @@
           <p:cNvPr id="27" name="table-text-578-3-0">
             <a:extLst xmlns:a="http://schemas.openxmlformats.org/drawingml/2006/main">
               <a:ext uri="{FF2B5EF4-FFF2-40B4-BE49-F238E27FC236}">
-                <a16:creationId xmlns:a16="http://schemas.microsoft.com/office/drawing/2014/main" id="{236F723A-2649-497D-A666-B239F3FE7089}"/>
+                <a16:creationId xmlns:a16="http://schemas.microsoft.com/office/drawing/2014/main" id="{9C234BB2-9B95-4FB0-B60F-62645B3489BF}"/>
               </a:ext>
             </a:extLst>
           </p:cNvPr>
@@ -11076,7 +11014,7 @@
           <p:cNvPr id="28" name="table-cell-578-3-1">
             <a:extLst xmlns:a="http://schemas.openxmlformats.org/drawingml/2006/main">
               <a:ext uri="{FF2B5EF4-FFF2-40B4-BE49-F238E27FC236}">
-                <a16:creationId xmlns:a16="http://schemas.microsoft.com/office/drawing/2014/main" id="{7D0D75C4-279C-47A7-A498-DD3BEA2C219D}"/>
+                <a16:creationId xmlns:a16="http://schemas.microsoft.com/office/drawing/2014/main" id="{DDD943D4-48DF-42D8-83C9-879287682064}"/>
               </a:ext>
             </a:extLst>
           </p:cNvPr>
@@ -11109,7 +11047,7 @@
           <p:cNvPr id="29" name="table-text-578-3-1">
             <a:extLst xmlns:a="http://schemas.openxmlformats.org/drawingml/2006/main">
               <a:ext uri="{FF2B5EF4-FFF2-40B4-BE49-F238E27FC236}">
-                <a16:creationId xmlns:a16="http://schemas.microsoft.com/office/drawing/2014/main" id="{4F572152-947E-42F9-B50A-1AFA6049FAA7}"/>
+                <a16:creationId xmlns:a16="http://schemas.microsoft.com/office/drawing/2014/main" id="{F1DC85EC-398C-491F-9C9E-6BF9360544E1}"/>
               </a:ext>
             </a:extLst>
           </p:cNvPr>
@@ -11171,7 +11109,7 @@
           <p:cNvPr id="30" name="table-cell-578-3-2">
             <a:extLst xmlns:a="http://schemas.openxmlformats.org/drawingml/2006/main">
               <a:ext uri="{FF2B5EF4-FFF2-40B4-BE49-F238E27FC236}">
-                <a16:creationId xmlns:a16="http://schemas.microsoft.com/office/drawing/2014/main" id="{4E24AED6-CC45-44E3-9A7A-E9B8FB78AA44}"/>
+                <a16:creationId xmlns:a16="http://schemas.microsoft.com/office/drawing/2014/main" id="{40FB4F8C-96FB-461F-A444-D2615433EBB5}"/>
               </a:ext>
             </a:extLst>
           </p:cNvPr>
@@ -11204,7 +11142,7 @@
           <p:cNvPr id="31" name="table-text-578-3-2">
             <a:extLst xmlns:a="http://schemas.openxmlformats.org/drawingml/2006/main">
               <a:ext uri="{FF2B5EF4-FFF2-40B4-BE49-F238E27FC236}">
-                <a16:creationId xmlns:a16="http://schemas.microsoft.com/office/drawing/2014/main" id="{C66F871A-DB92-49BB-8C1D-A0F493FB5187}"/>
+                <a16:creationId xmlns:a16="http://schemas.microsoft.com/office/drawing/2014/main" id="{94B45E5B-EA57-481B-B386-10BCE46437A2}"/>
               </a:ext>
             </a:extLst>
           </p:cNvPr>
@@ -11266,7 +11204,7 @@
           <p:cNvPr id="32" name="table-cell-578-4-0">
             <a:extLst xmlns:a="http://schemas.openxmlformats.org/drawingml/2006/main">
               <a:ext uri="{FF2B5EF4-FFF2-40B4-BE49-F238E27FC236}">
-                <a16:creationId xmlns:a16="http://schemas.microsoft.com/office/drawing/2014/main" id="{A90E93C2-B512-433E-8718-08E38F387A96}"/>
+                <a16:creationId xmlns:a16="http://schemas.microsoft.com/office/drawing/2014/main" id="{DC97FECB-404F-43FA-A5A8-F6251CF9DC3E}"/>
               </a:ext>
             </a:extLst>
           </p:cNvPr>
@@ -11299,7 +11237,7 @@
           <p:cNvPr id="33" name="table-text-578-4-0">
             <a:extLst xmlns:a="http://schemas.openxmlformats.org/drawingml/2006/main">
               <a:ext uri="{FF2B5EF4-FFF2-40B4-BE49-F238E27FC236}">
-                <a16:creationId xmlns:a16="http://schemas.microsoft.com/office/drawing/2014/main" id="{0E016AE5-B7B3-4D4B-B3B2-C9036BFD4F78}"/>
+                <a16:creationId xmlns:a16="http://schemas.microsoft.com/office/drawing/2014/main" id="{7767FA0A-42CE-4C41-B587-B5B00C81BC71}"/>
               </a:ext>
             </a:extLst>
           </p:cNvPr>
@@ -11361,7 +11299,7 @@
           <p:cNvPr id="34" name="table-cell-578-4-1">
             <a:extLst xmlns:a="http://schemas.openxmlformats.org/drawingml/2006/main">
               <a:ext uri="{FF2B5EF4-FFF2-40B4-BE49-F238E27FC236}">
-                <a16:creationId xmlns:a16="http://schemas.microsoft.com/office/drawing/2014/main" id="{BA6A6A07-CD95-454F-B88E-B04652CDF4A7}"/>
+                <a16:creationId xmlns:a16="http://schemas.microsoft.com/office/drawing/2014/main" id="{ACF85BEA-8A18-4C21-9A9E-4A39518F1B70}"/>
               </a:ext>
             </a:extLst>
           </p:cNvPr>
@@ -11394,7 +11332,7 @@
           <p:cNvPr id="35" name="table-text-578-4-1">
             <a:extLst xmlns:a="http://schemas.openxmlformats.org/drawingml/2006/main">
               <a:ext uri="{FF2B5EF4-FFF2-40B4-BE49-F238E27FC236}">
-                <a16:creationId xmlns:a16="http://schemas.microsoft.com/office/drawing/2014/main" id="{130CFA5C-7FF2-4519-AA81-40DEB9E346BA}"/>
+                <a16:creationId xmlns:a16="http://schemas.microsoft.com/office/drawing/2014/main" id="{970BE92E-9AE0-4F20-BB28-0047687710C4}"/>
               </a:ext>
             </a:extLst>
           </p:cNvPr>
@@ -11456,7 +11394,7 @@
           <p:cNvPr id="36" name="table-cell-578-4-2">
             <a:extLst xmlns:a="http://schemas.openxmlformats.org/drawingml/2006/main">
               <a:ext uri="{FF2B5EF4-FFF2-40B4-BE49-F238E27FC236}">
-                <a16:creationId xmlns:a16="http://schemas.microsoft.com/office/drawing/2014/main" id="{6B8165DD-3B62-4A4D-9C66-7B14B7EAA58E}"/>
+                <a16:creationId xmlns:a16="http://schemas.microsoft.com/office/drawing/2014/main" id="{ACED97F2-52C0-4C00-9C50-77A8F142EC6C}"/>
               </a:ext>
             </a:extLst>
           </p:cNvPr>
@@ -11489,7 +11427,7 @@
           <p:cNvPr id="37" name="table-text-578-4-2">
             <a:extLst xmlns:a="http://schemas.openxmlformats.org/drawingml/2006/main">
               <a:ext uri="{FF2B5EF4-FFF2-40B4-BE49-F238E27FC236}">
-                <a16:creationId xmlns:a16="http://schemas.microsoft.com/office/drawing/2014/main" id="{9C5A12D6-A87D-4C23-B3FB-A5694C1664DD}"/>
+                <a16:creationId xmlns:a16="http://schemas.microsoft.com/office/drawing/2014/main" id="{B7288D46-65A1-4171-912A-35041DC49C9A}"/>
               </a:ext>
             </a:extLst>
           </p:cNvPr>
@@ -11551,7 +11489,7 @@
           <p:cNvPr id="38" name="table-cell-578-5-0">
             <a:extLst xmlns:a="http://schemas.openxmlformats.org/drawingml/2006/main">
               <a:ext uri="{FF2B5EF4-FFF2-40B4-BE49-F238E27FC236}">
-                <a16:creationId xmlns:a16="http://schemas.microsoft.com/office/drawing/2014/main" id="{580D9BE7-153E-4E23-9A76-53CF968BDB0B}"/>
+                <a16:creationId xmlns:a16="http://schemas.microsoft.com/office/drawing/2014/main" id="{5A54B0E4-D714-4E5B-8F74-00605AB4A763}"/>
               </a:ext>
             </a:extLst>
           </p:cNvPr>
@@ -11584,7 +11522,7 @@
           <p:cNvPr id="39" name="table-text-578-5-0">
             <a:extLst xmlns:a="http://schemas.openxmlformats.org/drawingml/2006/main">
               <a:ext uri="{FF2B5EF4-FFF2-40B4-BE49-F238E27FC236}">
-                <a16:creationId xmlns:a16="http://schemas.microsoft.com/office/drawing/2014/main" id="{D19A8720-7D8D-41BB-8E3D-510A07ADE3ED}"/>
+                <a16:creationId xmlns:a16="http://schemas.microsoft.com/office/drawing/2014/main" id="{94211E37-5900-4A10-A9BD-9A7C1BA39C33}"/>
               </a:ext>
             </a:extLst>
           </p:cNvPr>
@@ -11646,7 +11584,7 @@
           <p:cNvPr id="40" name="table-cell-578-5-1">
             <a:extLst xmlns:a="http://schemas.openxmlformats.org/drawingml/2006/main">
               <a:ext uri="{FF2B5EF4-FFF2-40B4-BE49-F238E27FC236}">
-                <a16:creationId xmlns:a16="http://schemas.microsoft.com/office/drawing/2014/main" id="{D82F337E-7822-47BC-84E2-8AC080B8C983}"/>
+                <a16:creationId xmlns:a16="http://schemas.microsoft.com/office/drawing/2014/main" id="{A5BFB627-DDE5-42B8-A16B-9D6F2D2ADE06}"/>
               </a:ext>
             </a:extLst>
           </p:cNvPr>
@@ -11679,7 +11617,7 @@
           <p:cNvPr id="41" name="table-text-578-5-1">
             <a:extLst xmlns:a="http://schemas.openxmlformats.org/drawingml/2006/main">
               <a:ext uri="{FF2B5EF4-FFF2-40B4-BE49-F238E27FC236}">
-                <a16:creationId xmlns:a16="http://schemas.microsoft.com/office/drawing/2014/main" id="{BBE9D472-04F3-4B70-B7B6-17A5AA0353F6}"/>
+                <a16:creationId xmlns:a16="http://schemas.microsoft.com/office/drawing/2014/main" id="{42DD09EF-FA2B-43E9-A564-5C13A8D2329A}"/>
               </a:ext>
             </a:extLst>
           </p:cNvPr>
@@ -11741,7 +11679,7 @@
           <p:cNvPr id="42" name="table-cell-578-5-2">
             <a:extLst xmlns:a="http://schemas.openxmlformats.org/drawingml/2006/main">
               <a:ext uri="{FF2B5EF4-FFF2-40B4-BE49-F238E27FC236}">
-                <a16:creationId xmlns:a16="http://schemas.microsoft.com/office/drawing/2014/main" id="{6AD972D2-B77D-4249-BB5C-366F18E6DF0C}"/>
+                <a16:creationId xmlns:a16="http://schemas.microsoft.com/office/drawing/2014/main" id="{24D6069B-4DE6-4D5C-BD69-07C2070A6D52}"/>
               </a:ext>
             </a:extLst>
           </p:cNvPr>
@@ -11774,7 +11712,7 @@
           <p:cNvPr id="43" name="table-text-578-5-2">
             <a:extLst xmlns:a="http://schemas.openxmlformats.org/drawingml/2006/main">
               <a:ext uri="{FF2B5EF4-FFF2-40B4-BE49-F238E27FC236}">
-                <a16:creationId xmlns:a16="http://schemas.microsoft.com/office/drawing/2014/main" id="{5A4299A4-5A9D-4EC3-8230-CC2A84269BB1}"/>
+                <a16:creationId xmlns:a16="http://schemas.microsoft.com/office/drawing/2014/main" id="{523DE0E7-26E0-4855-95E9-B350D8176325}"/>
               </a:ext>
             </a:extLst>
           </p:cNvPr>
@@ -11836,7 +11774,7 @@
           <p:cNvPr id="44" name="paragraph-852">
             <a:extLst xmlns:a="http://schemas.openxmlformats.org/drawingml/2006/main">
               <a:ext uri="{FF2B5EF4-FFF2-40B4-BE49-F238E27FC236}">
-                <a16:creationId xmlns:a16="http://schemas.microsoft.com/office/drawing/2014/main" id="{FCB030E2-81A8-4D38-92DA-F8EBCD32D6F3}"/>
+                <a16:creationId xmlns:a16="http://schemas.microsoft.com/office/drawing/2014/main" id="{83C07C3B-C848-430E-9A59-BAA9F6976886}"/>
               </a:ext>
             </a:extLst>
           </p:cNvPr>
@@ -11896,7 +11834,7 @@
     </p:spTree>
     <p:extLst>
       <p:ext uri="{BB962C8B-B14F-4D97-AF65-F5344CB8AC3E}">
-        <p14:creationId xmlns:p14="http://schemas.microsoft.com/office/powerpoint/2010/main" val="2089170656"/>
+        <p14:creationId xmlns:p14="http://schemas.microsoft.com/office/powerpoint/2010/main" val="1519478569"/>
       </p:ext>
     </p:extLst>
   </p:cSld>
@@ -11927,7 +11865,7 @@
           <p:cNvPr id="11" name="running-label">
             <a:extLst xmlns:a="http://schemas.openxmlformats.org/drawingml/2006/main">
               <a:ext uri="{FF2B5EF4-FFF2-40B4-BE49-F238E27FC236}">
-                <a16:creationId xmlns:a16="http://schemas.microsoft.com/office/drawing/2014/main" id="{572CFD70-1EDE-4A3E-8845-000A6FBADD69}"/>
+                <a16:creationId xmlns:a16="http://schemas.microsoft.com/office/drawing/2014/main" id="{63A3AFBA-004C-43A7-AD10-5F9FF14B2815}"/>
               </a:ext>
             </a:extLst>
           </p:cNvPr>
@@ -11989,7 +11927,7 @@
           <p:cNvPr id="2" name="page-number">
             <a:extLst xmlns:a="http://schemas.openxmlformats.org/drawingml/2006/main">
               <a:ext uri="{FF2B5EF4-FFF2-40B4-BE49-F238E27FC236}">
-                <a16:creationId xmlns:a16="http://schemas.microsoft.com/office/drawing/2014/main" id="{E9E35E55-9B3E-462F-AED1-17CCE7016340}"/>
+                <a16:creationId xmlns:a16="http://schemas.microsoft.com/office/drawing/2014/main" id="{ECFCCF47-F373-45DD-84E6-E4DCB2147E5C}"/>
               </a:ext>
             </a:extLst>
           </p:cNvPr>
@@ -12051,7 +11989,7 @@
           <p:cNvPr id="3" name="header-rule">
             <a:extLst xmlns:a="http://schemas.openxmlformats.org/drawingml/2006/main">
               <a:ext uri="{FF2B5EF4-FFF2-40B4-BE49-F238E27FC236}">
-                <a16:creationId xmlns:a16="http://schemas.microsoft.com/office/drawing/2014/main" id="{F118032F-79CE-4319-899D-26A592E7C4FF}"/>
+                <a16:creationId xmlns:a16="http://schemas.microsoft.com/office/drawing/2014/main" id="{85912500-7A7D-4909-8D68-04C6BFAFB037}"/>
               </a:ext>
             </a:extLst>
           </p:cNvPr>
@@ -12082,7 +12020,7 @@
           <p:cNvPr id="4" name="slide-title">
             <a:extLst xmlns:a="http://schemas.openxmlformats.org/drawingml/2006/main">
               <a:ext uri="{FF2B5EF4-FFF2-40B4-BE49-F238E27FC236}">
-                <a16:creationId xmlns:a16="http://schemas.microsoft.com/office/drawing/2014/main" id="{A7E52301-D11A-4545-8DD1-BBFA042DC31C}"/>
+                <a16:creationId xmlns:a16="http://schemas.microsoft.com/office/drawing/2014/main" id="{11F3336C-3A31-4EE8-8F1D-2701A9C7BFD7}"/>
               </a:ext>
             </a:extLst>
           </p:cNvPr>
@@ -12144,7 +12082,7 @@
           <p:cNvPr id="5" name="subheading-140">
             <a:extLst xmlns:a="http://schemas.openxmlformats.org/drawingml/2006/main">
               <a:ext uri="{FF2B5EF4-FFF2-40B4-BE49-F238E27FC236}">
-                <a16:creationId xmlns:a16="http://schemas.microsoft.com/office/drawing/2014/main" id="{816C332E-B87D-4F4D-AECA-ADF3658108DA}"/>
+                <a16:creationId xmlns:a16="http://schemas.microsoft.com/office/drawing/2014/main" id="{BA33429A-2152-4E8D-AF6F-1A135A60AB21}"/>
               </a:ext>
             </a:extLst>
           </p:cNvPr>
@@ -12206,7 +12144,7 @@
           <p:cNvPr id="6" name="bullets-194">
             <a:extLst xmlns:a="http://schemas.openxmlformats.org/drawingml/2006/main">
               <a:ext uri="{FF2B5EF4-FFF2-40B4-BE49-F238E27FC236}">
-                <a16:creationId xmlns:a16="http://schemas.microsoft.com/office/drawing/2014/main" id="{48BF0041-8123-4FBA-837E-D7B956D477B6}"/>
+                <a16:creationId xmlns:a16="http://schemas.microsoft.com/office/drawing/2014/main" id="{F68D1468-47CB-4BC0-98A0-CEC245A76E3C}"/>
               </a:ext>
             </a:extLst>
           </p:cNvPr>
@@ -12395,7 +12333,7 @@
           <p:nvPr/>
         </p:nvPicPr>
         <p:blipFill>
-          <a:blip xmlns:r="http://schemas.openxmlformats.org/officeDocument/2006/relationships" xmlns:a="http://schemas.openxmlformats.org/drawingml/2006/main" r:embed="Rec054363a669451e"/>
+          <a:blip xmlns:r="http://schemas.openxmlformats.org/officeDocument/2006/relationships" xmlns:a="http://schemas.openxmlformats.org/drawingml/2006/main" r:embed="Rc2d9f38435104ce4"/>
           <a:stretch xmlns:a="http://schemas.openxmlformats.org/drawingml/2006/main"/>
         </p:blipFill>
         <p:spPr>
@@ -12415,7 +12353,7 @@
           <p:cNvPr id="8" name="image-caption-442.24">
             <a:extLst xmlns:a="http://schemas.openxmlformats.org/drawingml/2006/main">
               <a:ext uri="{FF2B5EF4-FFF2-40B4-BE49-F238E27FC236}">
-                <a16:creationId xmlns:a16="http://schemas.microsoft.com/office/drawing/2014/main" id="{DBFF1538-DC53-405C-878C-B0CE16D89356}"/>
+                <a16:creationId xmlns:a16="http://schemas.microsoft.com/office/drawing/2014/main" id="{B4EB4CB9-C2F0-4A09-A9FC-516E21F70A8F}"/>
               </a:ext>
             </a:extLst>
           </p:cNvPr>
@@ -12477,7 +12415,7 @@
           <p:cNvPr id="9" name="subheading-826.24">
             <a:extLst xmlns:a="http://schemas.openxmlformats.org/drawingml/2006/main">
               <a:ext uri="{FF2B5EF4-FFF2-40B4-BE49-F238E27FC236}">
-                <a16:creationId xmlns:a16="http://schemas.microsoft.com/office/drawing/2014/main" id="{B07A3532-3450-4EDC-99A3-023BA70969D6}"/>
+                <a16:creationId xmlns:a16="http://schemas.microsoft.com/office/drawing/2014/main" id="{156D3C30-BDF8-4F15-8CD3-20A6DAB49254}"/>
               </a:ext>
             </a:extLst>
           </p:cNvPr>
@@ -12539,7 +12477,7 @@
           <p:cNvPr id="10" name="paragraph-880.24">
             <a:extLst xmlns:a="http://schemas.openxmlformats.org/drawingml/2006/main">
               <a:ext uri="{FF2B5EF4-FFF2-40B4-BE49-F238E27FC236}">
-                <a16:creationId xmlns:a16="http://schemas.microsoft.com/office/drawing/2014/main" id="{71ACC2AF-CBCE-4A40-B299-4620ACE2DDE6}"/>
+                <a16:creationId xmlns:a16="http://schemas.microsoft.com/office/drawing/2014/main" id="{80140992-5E1E-483A-AC39-66DB16B5F0B5}"/>
               </a:ext>
             </a:extLst>
           </p:cNvPr>
@@ -12599,7 +12537,7 @@
     </p:spTree>
     <p:extLst>
       <p:ext uri="{BB962C8B-B14F-4D97-AF65-F5344CB8AC3E}">
-        <p14:creationId xmlns:p14="http://schemas.microsoft.com/office/powerpoint/2010/main" val="1683020507"/>
+        <p14:creationId xmlns:p14="http://schemas.microsoft.com/office/powerpoint/2010/main" val="2016967398"/>
       </p:ext>
     </p:extLst>
   </p:cSld>
@@ -12630,7 +12568,7 @@
           <p:cNvPr id="9" name="running-label">
             <a:extLst xmlns:a="http://schemas.openxmlformats.org/drawingml/2006/main">
               <a:ext uri="{FF2B5EF4-FFF2-40B4-BE49-F238E27FC236}">
-                <a16:creationId xmlns:a16="http://schemas.microsoft.com/office/drawing/2014/main" id="{14EE7F42-473C-42B8-83F0-84982B7581F2}"/>
+                <a16:creationId xmlns:a16="http://schemas.microsoft.com/office/drawing/2014/main" id="{F7FA8090-6E4A-4D2A-97E7-D9B60305322A}"/>
               </a:ext>
             </a:extLst>
           </p:cNvPr>
@@ -12692,7 +12630,7 @@
           <p:cNvPr id="2" name="page-number">
             <a:extLst xmlns:a="http://schemas.openxmlformats.org/drawingml/2006/main">
               <a:ext uri="{FF2B5EF4-FFF2-40B4-BE49-F238E27FC236}">
-                <a16:creationId xmlns:a16="http://schemas.microsoft.com/office/drawing/2014/main" id="{67C0F23E-1E9C-4DC8-9C02-23E3FEAC2020}"/>
+                <a16:creationId xmlns:a16="http://schemas.microsoft.com/office/drawing/2014/main" id="{29FCF0C5-3CD0-44FE-BCE6-2676E0E0021C}"/>
               </a:ext>
             </a:extLst>
           </p:cNvPr>
@@ -12754,7 +12692,7 @@
           <p:cNvPr id="3" name="header-rule">
             <a:extLst xmlns:a="http://schemas.openxmlformats.org/drawingml/2006/main">
               <a:ext uri="{FF2B5EF4-FFF2-40B4-BE49-F238E27FC236}">
-                <a16:creationId xmlns:a16="http://schemas.microsoft.com/office/drawing/2014/main" id="{4C402B94-F50C-4FF6-9431-E2EB536F5D9B}"/>
+                <a16:creationId xmlns:a16="http://schemas.microsoft.com/office/drawing/2014/main" id="{8A63C970-F9DC-4358-B8CC-AC625EB8C966}"/>
               </a:ext>
             </a:extLst>
           </p:cNvPr>
@@ -12785,7 +12723,7 @@
           <p:cNvPr id="4" name="slide-title">
             <a:extLst xmlns:a="http://schemas.openxmlformats.org/drawingml/2006/main">
               <a:ext uri="{FF2B5EF4-FFF2-40B4-BE49-F238E27FC236}">
-                <a16:creationId xmlns:a16="http://schemas.microsoft.com/office/drawing/2014/main" id="{2F553085-CB82-4171-99BF-611B9942E64B}"/>
+                <a16:creationId xmlns:a16="http://schemas.microsoft.com/office/drawing/2014/main" id="{F8E31A6A-11D2-4280-8A15-380C205179E3}"/>
               </a:ext>
             </a:extLst>
           </p:cNvPr>
@@ -12847,7 +12785,7 @@
           <p:cNvPr id="5" name="subheading-140">
             <a:extLst xmlns:a="http://schemas.openxmlformats.org/drawingml/2006/main">
               <a:ext uri="{FF2B5EF4-FFF2-40B4-BE49-F238E27FC236}">
-                <a16:creationId xmlns:a16="http://schemas.microsoft.com/office/drawing/2014/main" id="{5FA9A735-49D8-424F-AD18-FB1E4D16EC15}"/>
+                <a16:creationId xmlns:a16="http://schemas.microsoft.com/office/drawing/2014/main" id="{ADD6DE9B-E606-4044-A0D0-E1FB93555D1B}"/>
               </a:ext>
             </a:extLst>
           </p:cNvPr>
@@ -12909,7 +12847,7 @@
           <p:cNvPr id="6" name="paragraph-194">
             <a:extLst xmlns:a="http://schemas.openxmlformats.org/drawingml/2006/main">
               <a:ext uri="{FF2B5EF4-FFF2-40B4-BE49-F238E27FC236}">
-                <a16:creationId xmlns:a16="http://schemas.microsoft.com/office/drawing/2014/main" id="{B70DE555-7852-4197-939C-9EFBBA529BE9}"/>
+                <a16:creationId xmlns:a16="http://schemas.microsoft.com/office/drawing/2014/main" id="{029368A4-29F0-4A76-928E-8C53D55BFE67}"/>
               </a:ext>
             </a:extLst>
           </p:cNvPr>
@@ -12975,7 +12913,7 @@
           <p:nvPr/>
         </p:nvPicPr>
         <p:blipFill>
-          <a:blip xmlns:r="http://schemas.openxmlformats.org/officeDocument/2006/relationships" xmlns:a="http://schemas.openxmlformats.org/drawingml/2006/main" r:embed="R2568b3aca43743d1"/>
+          <a:blip xmlns:r="http://schemas.openxmlformats.org/officeDocument/2006/relationships" xmlns:a="http://schemas.openxmlformats.org/drawingml/2006/main" r:embed="R0bf3cb26dac14725"/>
           <a:stretch xmlns:a="http://schemas.openxmlformats.org/drawingml/2006/main"/>
         </p:blipFill>
         <p:spPr>
@@ -12995,7 +12933,7 @@
           <p:cNvPr id="8" name="image-caption-315.28">
             <a:extLst xmlns:a="http://schemas.openxmlformats.org/drawingml/2006/main">
               <a:ext uri="{FF2B5EF4-FFF2-40B4-BE49-F238E27FC236}">
-                <a16:creationId xmlns:a16="http://schemas.microsoft.com/office/drawing/2014/main" id="{AF4C1E98-691E-47D8-AE9F-C147201A3286}"/>
+                <a16:creationId xmlns:a16="http://schemas.microsoft.com/office/drawing/2014/main" id="{B81CFCB2-8601-4639-A263-8410D8C05062}"/>
               </a:ext>
             </a:extLst>
           </p:cNvPr>
@@ -13055,7 +12993,7 @@
     </p:spTree>
     <p:extLst>
       <p:ext uri="{BB962C8B-B14F-4D97-AF65-F5344CB8AC3E}">
-        <p14:creationId xmlns:p14="http://schemas.microsoft.com/office/powerpoint/2010/main" val="410302209"/>
+        <p14:creationId xmlns:p14="http://schemas.microsoft.com/office/powerpoint/2010/main" val="1491807475"/>
       </p:ext>
     </p:extLst>
   </p:cSld>
@@ -13086,7 +13024,7 @@
           <p:cNvPr id="8" name="running-label">
             <a:extLst xmlns:a="http://schemas.openxmlformats.org/drawingml/2006/main">
               <a:ext uri="{FF2B5EF4-FFF2-40B4-BE49-F238E27FC236}">
-                <a16:creationId xmlns:a16="http://schemas.microsoft.com/office/drawing/2014/main" id="{A5D8EFDA-421C-4070-AD10-195105D65483}"/>
+                <a16:creationId xmlns:a16="http://schemas.microsoft.com/office/drawing/2014/main" id="{06B30A6E-EB1A-4294-AA59-1CC5B933E8CE}"/>
               </a:ext>
             </a:extLst>
           </p:cNvPr>
@@ -13148,7 +13086,7 @@
           <p:cNvPr id="2" name="page-number">
             <a:extLst xmlns:a="http://schemas.openxmlformats.org/drawingml/2006/main">
               <a:ext uri="{FF2B5EF4-FFF2-40B4-BE49-F238E27FC236}">
-                <a16:creationId xmlns:a16="http://schemas.microsoft.com/office/drawing/2014/main" id="{326B8E8D-B994-4835-8CBD-29A7B61F57A2}"/>
+                <a16:creationId xmlns:a16="http://schemas.microsoft.com/office/drawing/2014/main" id="{A2732563-4BE0-4017-BD7C-03410FBB3A53}"/>
               </a:ext>
             </a:extLst>
           </p:cNvPr>
@@ -13210,7 +13148,7 @@
           <p:cNvPr id="3" name="header-rule">
             <a:extLst xmlns:a="http://schemas.openxmlformats.org/drawingml/2006/main">
               <a:ext uri="{FF2B5EF4-FFF2-40B4-BE49-F238E27FC236}">
-                <a16:creationId xmlns:a16="http://schemas.microsoft.com/office/drawing/2014/main" id="{EC51064E-1559-40AE-BBB8-CB91ACDED132}"/>
+                <a16:creationId xmlns:a16="http://schemas.microsoft.com/office/drawing/2014/main" id="{90A3BA39-202A-49AF-B3AE-A0F2D61332DB}"/>
               </a:ext>
             </a:extLst>
           </p:cNvPr>
@@ -13241,7 +13179,7 @@
           <p:cNvPr id="4" name="slide-title">
             <a:extLst xmlns:a="http://schemas.openxmlformats.org/drawingml/2006/main">
               <a:ext uri="{FF2B5EF4-FFF2-40B4-BE49-F238E27FC236}">
-                <a16:creationId xmlns:a16="http://schemas.microsoft.com/office/drawing/2014/main" id="{89472123-6359-4A4B-A978-466214807C5E}"/>
+                <a16:creationId xmlns:a16="http://schemas.microsoft.com/office/drawing/2014/main" id="{A370DEDF-59DC-49FC-9CCA-8A9934558E4B}"/>
               </a:ext>
             </a:extLst>
           </p:cNvPr>
@@ -13307,7 +13245,7 @@
           <p:nvPr/>
         </p:nvPicPr>
         <p:blipFill>
-          <a:blip xmlns:r="http://schemas.openxmlformats.org/officeDocument/2006/relationships" xmlns:a="http://schemas.openxmlformats.org/drawingml/2006/main" r:embed="Rb84102cf3cd940af"/>
+          <a:blip xmlns:r="http://schemas.openxmlformats.org/officeDocument/2006/relationships" xmlns:a="http://schemas.openxmlformats.org/drawingml/2006/main" r:embed="Rdb495323f0664230"/>
           <a:stretch xmlns:a="http://schemas.openxmlformats.org/drawingml/2006/main"/>
         </p:blipFill>
         <p:spPr>
@@ -13327,7 +13265,7 @@
           <p:cNvPr id="6" name="image-caption-140">
             <a:extLst xmlns:a="http://schemas.openxmlformats.org/drawingml/2006/main">
               <a:ext uri="{FF2B5EF4-FFF2-40B4-BE49-F238E27FC236}">
-                <a16:creationId xmlns:a16="http://schemas.microsoft.com/office/drawing/2014/main" id="{9A3641CE-DB2D-4F50-A4D7-536E4205A714}"/>
+                <a16:creationId xmlns:a16="http://schemas.microsoft.com/office/drawing/2014/main" id="{24EC01F6-657C-417F-9BE3-7498A676D29E}"/>
               </a:ext>
             </a:extLst>
           </p:cNvPr>
@@ -13389,7 +13327,7 @@
           <p:cNvPr id="7" name="paragraph-524">
             <a:extLst xmlns:a="http://schemas.openxmlformats.org/drawingml/2006/main">
               <a:ext uri="{FF2B5EF4-FFF2-40B4-BE49-F238E27FC236}">
-                <a16:creationId xmlns:a16="http://schemas.microsoft.com/office/drawing/2014/main" id="{6BFAA53B-59C9-4EA8-A115-3EC75C9F1678}"/>
+                <a16:creationId xmlns:a16="http://schemas.microsoft.com/office/drawing/2014/main" id="{BE94A4AF-6D0F-44B1-9C83-B9462FEBCD76}"/>
               </a:ext>
             </a:extLst>
           </p:cNvPr>
@@ -13449,7 +13387,7 @@
     </p:spTree>
     <p:extLst>
       <p:ext uri="{BB962C8B-B14F-4D97-AF65-F5344CB8AC3E}">
-        <p14:creationId xmlns:p14="http://schemas.microsoft.com/office/powerpoint/2010/main" val="164690411"/>
+        <p14:creationId xmlns:p14="http://schemas.microsoft.com/office/powerpoint/2010/main" val="1269535190"/>
       </p:ext>
     </p:extLst>
   </p:cSld>

</xml_diff>